<commit_message>
Compare meeting slides against the unmodified lab model
Co-Authored-By: Claude Opus 5.5 (1M context) <noreply@anthropic.com>
</commit_message>
<xml_diff>
--- a/weekly_reports/pptx/20261014_人流予測の仕組みと精度.pptx
+++ b/weekly_reports/pptx/20261014_人流予測の仕組みと精度.pptx
@@ -13,9 +13,10 @@
     <p:sldId id="261" r:id="rId7"/>
     <p:sldId id="262" r:id="rId8"/>
     <p:sldId id="263" r:id="rId9"/>
+    <p:sldId id="264" r:id="rId10"/>
   </p:sldIdLst>
   <p:notesMasterIdLst>
-    <p:notesMasterId r:id="rId10"/>
+    <p:notesMasterId r:id="rId11"/>
   </p:notesMasterIdLst>
   <p:sldSz cx="9144000" cy="5143500"/>
   <p:notesSz cx="5143500" cy="9144000"/>
@@ -224,7 +225,7 @@
               <c:strCache>
                 <c:ptCount val="1"/>
                 <c:pt idx="0">
-                  <c:v>旧モデル（2%）</c:v>
+                  <c:v>研究室モデル（2%）</c:v>
                 </c:pt>
               </c:strCache>
             </c:strRef>
@@ -289,13 +290,13 @@
                 <c:formatCode>General</c:formatCode>
                 <c:ptCount val="4"/>
                 <c:pt idx="0">
-                  <c:v>32.6</c:v>
+                  <c:v>10.4</c:v>
                 </c:pt>
                 <c:pt idx="1">
-                  <c:v>50.7</c:v>
+                  <c:v>59.9</c:v>
                 </c:pt>
                 <c:pt idx="2">
-                  <c:v>16.7</c:v>
+                  <c:v>29.7</c:v>
                 </c:pt>
                 <c:pt idx="3">
                   <c:v>0</c:v>
@@ -313,7 +314,7 @@
               <c:strCache>
                 <c:ptCount val="1"/>
                 <c:pt idx="0">
-                  <c:v>新モデル（全数）</c:v>
+                  <c:v>今回のモデル（全数）</c:v>
                 </c:pt>
               </c:strCache>
             </c:strRef>
@@ -468,7 +469,7 @@
         <c:axId val="2094734552"/>
         <c:scaling>
           <c:orientation val="minMax"/>
-          <c:max val="60"/>
+          <c:max val="70"/>
         </c:scaling>
         <c:delete val="0"/>
         <c:axPos val="l"/>
@@ -606,7 +607,7 @@
               <c:strCache>
                 <c:ptCount val="1"/>
                 <c:pt idx="0">
-                  <c:v>旧モデル</c:v>
+                  <c:v>研究室モデル</c:v>
                 </c:pt>
               </c:strCache>
             </c:strRef>
@@ -671,16 +672,16 @@
                 <c:formatCode>General</c:formatCode>
                 <c:ptCount val="4"/>
                 <c:pt idx="0">
-                  <c:v>0.396</c:v>
+                  <c:v>0.569</c:v>
                 </c:pt>
                 <c:pt idx="1">
-                  <c:v>0.467</c:v>
+                  <c:v>0.539</c:v>
                 </c:pt>
                 <c:pt idx="2">
-                  <c:v>0.426</c:v>
+                  <c:v>0.523</c:v>
                 </c:pt>
                 <c:pt idx="3">
-                  <c:v>0.435</c:v>
+                  <c:v>0.597</c:v>
                 </c:pt>
               </c:numCache>
             </c:numRef>
@@ -695,7 +696,7 @@
               <c:strCache>
                 <c:ptCount val="1"/>
                 <c:pt idx="0">
-                  <c:v>新モデル</c:v>
+                  <c:v>今回のモデル</c:v>
                 </c:pt>
               </c:strCache>
             </c:strRef>
@@ -850,7 +851,7 @@
         <c:axId val="2094734552"/>
         <c:scaling>
           <c:orientation val="minMax"/>
-          <c:max val="0.5"/>
+          <c:max val="0.7"/>
           <c:min val="0"/>
         </c:scaling>
         <c:delete val="0"/>
@@ -2003,6 +2004,94 @@
             <a:fld id="{F7021451-1387-4CA6-816F-3879F97B5CBC}" type="slidenum">
               <a:rPr lang="en-US"/>
               <a:t>8</a:t>
+            </a:fld>
+            <a:endParaRPr lang="en-US"/>
+          </a:p>
+        </p:txBody>
+      </p:sp>
+    </p:spTree>
+    <p:extLst>
+      <p:ext uri="{BB962C8B-B14F-4D97-AF65-F5344CB8AC3E}">
+        <p14:creationId xmlns:p14="http://schemas.microsoft.com/office/powerpoint/2010/main" val="1024086991"/>
+      </p:ext>
+    </p:extLst>
+  </p:cSld>
+  <p:clrMapOvr>
+    <a:masterClrMapping/>
+  </p:clrMapOvr>
+</p:notes>
+</file>
+
+<file path=ppt/notesSlides/notesSlide9.xml><?xml version="1.0" encoding="utf-8"?>
+<p:notes xmlns:a="http://schemas.openxmlformats.org/drawingml/2006/main" xmlns:r="http://schemas.openxmlformats.org/officeDocument/2006/relationships" xmlns:p="http://schemas.openxmlformats.org/presentationml/2006/main">
+  <p:cSld>
+    <p:spTree>
+      <p:nvGrpSpPr>
+        <p:cNvPr id="1" name=""/>
+        <p:cNvGrpSpPr/>
+        <p:nvPr/>
+      </p:nvGrpSpPr>
+      <p:grpSpPr>
+        <a:xfrm>
+          <a:off x="0" y="0"/>
+          <a:ext cx="0" cy="0"/>
+          <a:chOff x="0" y="0"/>
+          <a:chExt cx="0" cy="0"/>
+        </a:xfrm>
+      </p:grpSpPr>
+      <p:sp>
+        <p:nvSpPr>
+          <p:cNvPr id="2" name="Slide Image Placeholder 1"/>
+          <p:cNvSpPr>
+            <a:spLocks noGrp="1" noRot="1" noChangeAspect="1"/>
+          </p:cNvSpPr>
+          <p:nvPr>
+            <p:ph type="sldImg"/>
+          </p:nvPr>
+        </p:nvSpPr>
+        <p:spPr/>
+      </p:sp>
+      <p:sp>
+        <p:nvSpPr>
+          <p:cNvPr id="3" name="Notes Placeholder 2"/>
+          <p:cNvSpPr>
+            <a:spLocks noGrp="1"/>
+          </p:cNvSpPr>
+          <p:nvPr>
+            <p:ph type="body" idx="1"/>
+          </p:nvPr>
+        </p:nvSpPr>
+        <p:spPr/>
+        <p:txBody>
+          <a:bodyPr/>
+          <a:lstStyle/>
+          <a:p>
+            <a:r>
+              <a:rPr lang="en-US" dirty="0"/>
+              <a:t/>
+            </a:r>
+            <a:endParaRPr lang="en-US" dirty="0"/>
+          </a:p>
+        </p:txBody>
+      </p:sp>
+      <p:sp>
+        <p:nvSpPr>
+          <p:cNvPr id="4" name="Slide Number Placeholder 3"/>
+          <p:cNvSpPr>
+            <a:spLocks noGrp="1"/>
+          </p:cNvSpPr>
+          <p:nvPr>
+            <p:ph type="sldNum" sz="quarter" idx="10"/>
+          </p:nvPr>
+        </p:nvSpPr>
+        <p:spPr/>
+        <p:txBody>
+          <a:bodyPr/>
+          <a:lstStyle/>
+          <a:p>
+            <a:fld id="{F7021451-1387-4CA6-816F-3879F97B5CBC}" type="slidenum">
+              <a:rPr lang="en-US"/>
+              <a:t>9</a:t>
             </a:fld>
             <a:endParaRPr lang="en-US"/>
           </a:p>
@@ -6512,7 +6601,7 @@
                 <a:ea typeface="游ゴシック" pitchFamily="34" charset="-122"/>
                 <a:cs typeface="游ゴシック" pitchFamily="34" charset="-120"/>
               </a:rPr>
-              <a:t>旧モデル　0.396</a:t>
+              <a:t>研究室モデル　0.569</a:t>
             </a:r>
             <a:endParaRPr lang="en-US" sz="1400" dirty="0"/>
           </a:p>
@@ -6529,7 +6618,7 @@
                 <a:ea typeface="游ゴシック" pitchFamily="34" charset="-122"/>
                 <a:cs typeface="游ゴシック" pitchFamily="34" charset="-120"/>
               </a:rPr>
-              <a:t>新モデル　0.348</a:t>
+              <a:t>今回のモデル　0.348</a:t>
             </a:r>
             <a:endParaRPr lang="en-US" sz="1400" dirty="0"/>
           </a:p>
@@ -6563,7 +6652,7 @@
                 <a:ea typeface="游ゴシック" pitchFamily="34" charset="-122"/>
                 <a:cs typeface="游ゴシック" pitchFamily="34" charset="-120"/>
               </a:rPr>
-              <a:t>改善：市内他区の過大（51→41%）、遠方の欠け</a:t>
+              <a:t>改善：研究室モデルは区内10%と少なすぎ、市内他区60%と多すぎ。今回は他区41%でPTと一致</a:t>
             </a:r>
             <a:endParaRPr lang="en-US" sz="1400" dirty="0"/>
           </a:p>
@@ -6580,7 +6669,7 @@
                 <a:ea typeface="游ゴシック" pitchFamily="34" charset="-122"/>
                 <a:cs typeface="游ゴシック" pitchFamily="34" charset="-120"/>
               </a:rPr>
-              <a:t>残る課題：中村区内が多い（45% vs 34%）、県外は生成対象外（6%）</a:t>
+              <a:t>残る課題：今度は中村区内が多い（45% vs 34%）。県外は生成対象外（6%）</a:t>
             </a:r>
             <a:endParaRPr lang="en-US" sz="1400" dirty="0"/>
           </a:p>
@@ -6619,7 +6708,7 @@
                 <a:ea typeface="游ゴシック" pitchFamily="34" charset="-122"/>
                 <a:cs typeface="游ゴシック" pitchFamily="34" charset="-120"/>
               </a:rPr>
-              <a:t>旧モデル＝10/9採用設定（seed42、2%）。新モデル＝全数seed42。TVDは校正に使った指標そのもので外部検証ではない</a:t>
+              <a:t>研究室モデル＝改良オプションなしのPseudo-PFLOW-v3に同じ計画（+746人、施設capacity 800万）を入れたもの（seed42、2%）。今回＝全数seed42。TVDは校正に使った指標そのもので外部検証ではない</a:t>
             </a:r>
             <a:endParaRPr lang="en-US" sz="1000" dirty="0"/>
           </a:p>
@@ -6804,7 +6893,7 @@
                           <a:ea typeface="游ゴシック" pitchFamily="34" charset="-122"/>
                           <a:cs typeface="游ゴシック" pitchFamily="34" charset="-120"/>
                         </a:rPr>
-                        <a:t>旧</a:t>
+                        <a:t>研究室</a:t>
                       </a:r>
                       <a:endParaRPr lang="en-US" sz="1100" dirty="0">
                         <a:latin typeface="游ゴシック" charset="0"/>
@@ -6869,7 +6958,7 @@
                           <a:ea typeface="游ゴシック" pitchFamily="34" charset="-122"/>
                           <a:cs typeface="游ゴシック" pitchFamily="34" charset="-120"/>
                         </a:rPr>
-                        <a:t>新</a:t>
+                        <a:t>今回</a:t>
                       </a:r>
                       <a:endParaRPr lang="en-US" sz="1100" dirty="0">
                         <a:latin typeface="游ゴシック" charset="0"/>
@@ -7001,7 +7090,7 @@
                           <a:ea typeface="游ゴシック" pitchFamily="34" charset="-122"/>
                           <a:cs typeface="游ゴシック" pitchFamily="34" charset="-120"/>
                         </a:rPr>
-                        <a:t>0.431</a:t>
+                        <a:t>0.557</a:t>
                       </a:r>
                       <a:endParaRPr lang="en-US" sz="1100" dirty="0">
                         <a:latin typeface="游ゴシック" charset="0"/>
@@ -7198,7 +7287,7 @@
                           <a:ea typeface="游ゴシック" pitchFamily="34" charset="-122"/>
                           <a:cs typeface="游ゴシック" pitchFamily="34" charset="-120"/>
                         </a:rPr>
-                        <a:t>0.422</a:t>
+                        <a:t>0.548</a:t>
                       </a:r>
                       <a:endParaRPr lang="en-US" sz="1100" dirty="0">
                         <a:latin typeface="游ゴシック" charset="0"/>
@@ -7395,7 +7484,7 @@
                           <a:ea typeface="游ゴシック" pitchFamily="34" charset="-122"/>
                           <a:cs typeface="游ゴシック" pitchFamily="34" charset="-120"/>
                         </a:rPr>
-                        <a:t>385件</a:t>
+                        <a:t>198件</a:t>
                       </a:r>
                       <a:endParaRPr lang="en-US" sz="1100" dirty="0">
                         <a:latin typeface="游ゴシック" charset="0"/>
@@ -7452,9 +7541,9 @@
                         <a:buNone/>
                       </a:pPr>
                       <a:r>
-                        <a:rPr lang="en-US" sz="1100" dirty="0">
+                        <a:rPr lang="en-US" sz="1100" b="1" dirty="0">
                           <a:solidFill>
-                            <a:srgbClr val="222222"/>
+                            <a:srgbClr val="1F6FB2"/>
                           </a:solidFill>
                           <a:latin typeface="游ゴシック" pitchFamily="34" charset="0"/>
                           <a:ea typeface="游ゴシック" pitchFamily="34" charset="-122"/>
@@ -7527,7 +7616,7 @@
                           <a:ea typeface="游ゴシック" pitchFamily="34" charset="-122"/>
                           <a:cs typeface="游ゴシック" pitchFamily="34" charset="-120"/>
                         </a:rPr>
-                        <a:t>到着のばらつき（標準偏差）</a:t>
+                        <a:t>capacity 1e9での到着（seed42）</a:t>
                       </a:r>
                       <a:endParaRPr lang="en-US" sz="1100" dirty="0">
                         <a:latin typeface="游ゴシック" charset="0"/>
@@ -7592,7 +7681,7 @@
                           <a:ea typeface="游ゴシック" pitchFamily="34" charset="-122"/>
                           <a:cs typeface="游ゴシック" pitchFamily="34" charset="-120"/>
                         </a:rPr>
-                        <a:t>16件</a:t>
+                        <a:t>265件</a:t>
                       </a:r>
                       <a:endParaRPr lang="en-US" sz="1100" dirty="0">
                         <a:latin typeface="游ゴシック" charset="0"/>
@@ -7657,7 +7746,7 @@
                           <a:ea typeface="游ゴシック" pitchFamily="34" charset="-122"/>
                           <a:cs typeface="游ゴシック" pitchFamily="34" charset="-120"/>
                         </a:rPr>
-                        <a:t>24件</a:t>
+                        <a:t>360件</a:t>
                       </a:r>
                       <a:endParaRPr lang="en-US" sz="1100" dirty="0">
                         <a:latin typeface="游ゴシック" charset="0"/>
@@ -7743,7 +7832,7 @@
                 <a:ea typeface="游ゴシック" pitchFamily="34" charset="-122"/>
                 <a:cs typeface="游ゴシック" pitchFamily="34" charset="-120"/>
               </a:rPr>
-              <a:t>4つのseedすべてで新モデルの方が小さい。seed42は校正に使ったので、43〜45が設定を変えずに確かめた結果</a:t>
+              <a:t>4つのseedすべてで今回の方が小さい。研究室モデルはcapacityを上げても目標人数に届かない。seed42は校正に使い、43〜45は設定を変えずに確かめた結果</a:t>
             </a:r>
             <a:endParaRPr lang="en-US" sz="1200" dirty="0"/>
           </a:p>
@@ -7782,7 +7871,7 @@
                 <a:ea typeface="游ゴシック" pitchFamily="34" charset="-122"/>
                 <a:cs typeface="游ゴシック" pitchFamily="34" charset="-120"/>
               </a:rPr>
-              <a:t>旧モデルも今回と同じ参照（中ゾーン5の大型店・買物）で計算し直した値</a:t>
+              <a:t>研究室モデルにも同じ計画を入れ、同じ参照（中ゾーン5の大型店・買物）で計算。到着の標準偏差は研究室12件、今回24件</a:t>
             </a:r>
             <a:endParaRPr lang="en-US" sz="1000" dirty="0"/>
           </a:p>
@@ -7846,7 +7935,2492 @@
                 <a:ea typeface="游ゴシック" pitchFamily="34" charset="-122"/>
                 <a:cs typeface="游ゴシック" pitchFamily="34" charset="-120"/>
               </a:rPr>
-              <a:t>精度③　全数（100%）で実行した結果</a:t>
+              <a:t>精度③　愛知全体では研究室の方が良い点も</a:t>
+            </a:r>
+            <a:endParaRPr lang="en-US" sz="2800" dirty="0"/>
+          </a:p>
+        </p:txBody>
+      </p:sp>
+      <p:graphicFrame>
+        <p:nvGraphicFramePr>
+          <p:cNvPr id="8" name="Table 0"/>
+          <p:cNvGraphicFramePr>
+            <a:graphicFrameLocks noGrp="1"/>
+          </p:cNvGraphicFramePr>
+          <p:nvPr>
+            <p:extLst>
+              <p:ext uri="{D42A27DB-BD31-4B8C-83A1-F6EECF244321}">
+                <p14:modId xmlns:p14="http://schemas.microsoft.com/office/powerpoint/2010/main" val="1579011935"/>
+              </p:ext>
+            </p:extLst>
+          </p:nvPr>
+        </p:nvGraphicFramePr>
+        <p:xfrm>
+          <a:off x="365760" y="914400"/>
+          <a:ext cx="8412480" cy="914400"/>
+        </p:xfrm>
+        <a:graphic>
+          <a:graphicData uri="http://schemas.openxmlformats.org/drawingml/2006/table">
+            <a:tbl>
+              <a:tblPr/>
+              <a:tblGrid>
+                <a:gridCol w="3017520"/>
+                <a:gridCol w="1645920"/>
+                <a:gridCol w="1737360"/>
+                <a:gridCol w="1005840"/>
+                <a:gridCol w="1005840"/>
+              </a:tblGrid>
+              <a:tr h="365760">
+                <a:tc>
+                  <a:txBody>
+                    <a:bodyPr/>
+                    <a:lstStyle/>
+                    <a:p>
+                      <a:pPr indent="0" marL="0">
+                        <a:buNone/>
+                      </a:pPr>
+                      <a:r>
+                        <a:rPr lang="en-US" sz="1100" b="1" dirty="0">
+                          <a:solidFill>
+                            <a:srgbClr val="222222"/>
+                          </a:solidFill>
+                          <a:latin typeface="游ゴシック" pitchFamily="34" charset="0"/>
+                          <a:ea typeface="游ゴシック" pitchFamily="34" charset="-122"/>
+                          <a:cs typeface="游ゴシック" pitchFamily="34" charset="-120"/>
+                        </a:rPr>
+                        <a:t>指標</a:t>
+                      </a:r>
+                      <a:endParaRPr lang="en-US" sz="1100" dirty="0">
+                        <a:latin typeface="游ゴシック" charset="0"/>
+                        <a:ea typeface="游ゴシック" charset="0"/>
+                        <a:cs typeface="游ゴシック" charset="0"/>
+                      </a:endParaRPr>
+                    </a:p>
+                  </a:txBody>
+                  <a:tcPr marL="91440" marR="91440" marT="45720" marB="45720">
+                    <a:lnL w="6350" cap="flat" cmpd="sng" algn="ctr">
+                      <a:solidFill>
+                        <a:srgbClr val="BBBBBB"/>
+                      </a:solidFill>
+                      <a:prstDash val="solid"/>
+                      <a:round/>
+                      <a:headEnd type="none" w="med" len="med"/>
+                      <a:tailEnd type="none" w="med" len="med"/>
+                    </a:lnL>
+                    <a:lnR w="6350" cap="flat" cmpd="sng" algn="ctr">
+                      <a:solidFill>
+                        <a:srgbClr val="BBBBBB"/>
+                      </a:solidFill>
+                      <a:prstDash val="solid"/>
+                      <a:round/>
+                      <a:headEnd type="none" w="med" len="med"/>
+                      <a:tailEnd type="none" w="med" len="med"/>
+                    </a:lnR>
+                    <a:lnT w="6350" cap="flat" cmpd="sng" algn="ctr">
+                      <a:solidFill>
+                        <a:srgbClr val="BBBBBB"/>
+                      </a:solidFill>
+                      <a:prstDash val="solid"/>
+                      <a:round/>
+                      <a:headEnd type="none" w="med" len="med"/>
+                      <a:tailEnd type="none" w="med" len="med"/>
+                    </a:lnT>
+                    <a:lnB w="6350" cap="flat" cmpd="sng" algn="ctr">
+                      <a:solidFill>
+                        <a:srgbClr val="BBBBBB"/>
+                      </a:solidFill>
+                      <a:prstDash val="solid"/>
+                      <a:round/>
+                      <a:headEnd type="none" w="med" len="med"/>
+                      <a:tailEnd type="none" w="med" len="med"/>
+                    </a:lnB>
+                  </a:tcPr>
+                </a:tc>
+                <a:tc>
+                  <a:txBody>
+                    <a:bodyPr/>
+                    <a:lstStyle/>
+                    <a:p>
+                      <a:pPr indent="0" marL="0">
+                        <a:buNone/>
+                      </a:pPr>
+                      <a:r>
+                        <a:rPr lang="en-US" sz="1100" b="1" dirty="0">
+                          <a:solidFill>
+                            <a:srgbClr val="222222"/>
+                          </a:solidFill>
+                          <a:latin typeface="游ゴシック" pitchFamily="34" charset="0"/>
+                          <a:ea typeface="游ゴシック" pitchFamily="34" charset="-122"/>
+                          <a:cs typeface="游ゴシック" pitchFamily="34" charset="-120"/>
+                        </a:rPr>
+                        <a:t>研究室</a:t>
+                      </a:r>
+                      <a:endParaRPr lang="en-US" sz="1100" dirty="0">
+                        <a:latin typeface="游ゴシック" charset="0"/>
+                        <a:ea typeface="游ゴシック" charset="0"/>
+                        <a:cs typeface="游ゴシック" charset="0"/>
+                      </a:endParaRPr>
+                    </a:p>
+                  </a:txBody>
+                  <a:tcPr marL="91440" marR="91440" marT="45720" marB="45720">
+                    <a:lnL w="6350" cap="flat" cmpd="sng" algn="ctr">
+                      <a:solidFill>
+                        <a:srgbClr val="BBBBBB"/>
+                      </a:solidFill>
+                      <a:prstDash val="solid"/>
+                      <a:round/>
+                      <a:headEnd type="none" w="med" len="med"/>
+                      <a:tailEnd type="none" w="med" len="med"/>
+                    </a:lnL>
+                    <a:lnR w="6350" cap="flat" cmpd="sng" algn="ctr">
+                      <a:solidFill>
+                        <a:srgbClr val="BBBBBB"/>
+                      </a:solidFill>
+                      <a:prstDash val="solid"/>
+                      <a:round/>
+                      <a:headEnd type="none" w="med" len="med"/>
+                      <a:tailEnd type="none" w="med" len="med"/>
+                    </a:lnR>
+                    <a:lnT w="6350" cap="flat" cmpd="sng" algn="ctr">
+                      <a:solidFill>
+                        <a:srgbClr val="BBBBBB"/>
+                      </a:solidFill>
+                      <a:prstDash val="solid"/>
+                      <a:round/>
+                      <a:headEnd type="none" w="med" len="med"/>
+                      <a:tailEnd type="none" w="med" len="med"/>
+                    </a:lnT>
+                    <a:lnB w="6350" cap="flat" cmpd="sng" algn="ctr">
+                      <a:solidFill>
+                        <a:srgbClr val="BBBBBB"/>
+                      </a:solidFill>
+                      <a:prstDash val="solid"/>
+                      <a:round/>
+                      <a:headEnd type="none" w="med" len="med"/>
+                      <a:tailEnd type="none" w="med" len="med"/>
+                    </a:lnB>
+                  </a:tcPr>
+                </a:tc>
+                <a:tc>
+                  <a:txBody>
+                    <a:bodyPr/>
+                    <a:lstStyle/>
+                    <a:p>
+                      <a:pPr indent="0" marL="0">
+                        <a:buNone/>
+                      </a:pPr>
+                      <a:r>
+                        <a:rPr lang="en-US" sz="1100" b="1" dirty="0">
+                          <a:solidFill>
+                            <a:srgbClr val="222222"/>
+                          </a:solidFill>
+                          <a:latin typeface="游ゴシック" pitchFamily="34" charset="0"/>
+                          <a:ea typeface="游ゴシック" pitchFamily="34" charset="-122"/>
+                          <a:cs typeface="游ゴシック" pitchFamily="34" charset="-120"/>
+                        </a:rPr>
+                        <a:t>今回</a:t>
+                      </a:r>
+                      <a:endParaRPr lang="en-US" sz="1100" dirty="0">
+                        <a:latin typeface="游ゴシック" charset="0"/>
+                        <a:ea typeface="游ゴシック" charset="0"/>
+                        <a:cs typeface="游ゴシック" charset="0"/>
+                      </a:endParaRPr>
+                    </a:p>
+                  </a:txBody>
+                  <a:tcPr marL="91440" marR="91440" marT="45720" marB="45720">
+                    <a:lnL w="6350" cap="flat" cmpd="sng" algn="ctr">
+                      <a:solidFill>
+                        <a:srgbClr val="BBBBBB"/>
+                      </a:solidFill>
+                      <a:prstDash val="solid"/>
+                      <a:round/>
+                      <a:headEnd type="none" w="med" len="med"/>
+                      <a:tailEnd type="none" w="med" len="med"/>
+                    </a:lnL>
+                    <a:lnR w="6350" cap="flat" cmpd="sng" algn="ctr">
+                      <a:solidFill>
+                        <a:srgbClr val="BBBBBB"/>
+                      </a:solidFill>
+                      <a:prstDash val="solid"/>
+                      <a:round/>
+                      <a:headEnd type="none" w="med" len="med"/>
+                      <a:tailEnd type="none" w="med" len="med"/>
+                    </a:lnR>
+                    <a:lnT w="6350" cap="flat" cmpd="sng" algn="ctr">
+                      <a:solidFill>
+                        <a:srgbClr val="BBBBBB"/>
+                      </a:solidFill>
+                      <a:prstDash val="solid"/>
+                      <a:round/>
+                      <a:headEnd type="none" w="med" len="med"/>
+                      <a:tailEnd type="none" w="med" len="med"/>
+                    </a:lnT>
+                    <a:lnB w="6350" cap="flat" cmpd="sng" algn="ctr">
+                      <a:solidFill>
+                        <a:srgbClr val="BBBBBB"/>
+                      </a:solidFill>
+                      <a:prstDash val="solid"/>
+                      <a:round/>
+                      <a:headEnd type="none" w="med" len="med"/>
+                      <a:tailEnd type="none" w="med" len="med"/>
+                    </a:lnB>
+                  </a:tcPr>
+                </a:tc>
+                <a:tc>
+                  <a:txBody>
+                    <a:bodyPr/>
+                    <a:lstStyle/>
+                    <a:p>
+                      <a:pPr indent="0" marL="0">
+                        <a:buNone/>
+                      </a:pPr>
+                      <a:r>
+                        <a:rPr lang="en-US" sz="1100" b="1" dirty="0">
+                          <a:solidFill>
+                            <a:srgbClr val="222222"/>
+                          </a:solidFill>
+                          <a:latin typeface="游ゴシック" pitchFamily="34" charset="0"/>
+                          <a:ea typeface="游ゴシック" pitchFamily="34" charset="-122"/>
+                          <a:cs typeface="游ゴシック" pitchFamily="34" charset="-120"/>
+                        </a:rPr>
+                        <a:t>PT</a:t>
+                      </a:r>
+                      <a:endParaRPr lang="en-US" sz="1100" dirty="0">
+                        <a:latin typeface="游ゴシック" charset="0"/>
+                        <a:ea typeface="游ゴシック" charset="0"/>
+                        <a:cs typeface="游ゴシック" charset="0"/>
+                      </a:endParaRPr>
+                    </a:p>
+                  </a:txBody>
+                  <a:tcPr marL="91440" marR="91440" marT="45720" marB="45720">
+                    <a:lnL w="6350" cap="flat" cmpd="sng" algn="ctr">
+                      <a:solidFill>
+                        <a:srgbClr val="BBBBBB"/>
+                      </a:solidFill>
+                      <a:prstDash val="solid"/>
+                      <a:round/>
+                      <a:headEnd type="none" w="med" len="med"/>
+                      <a:tailEnd type="none" w="med" len="med"/>
+                    </a:lnL>
+                    <a:lnR w="6350" cap="flat" cmpd="sng" algn="ctr">
+                      <a:solidFill>
+                        <a:srgbClr val="BBBBBB"/>
+                      </a:solidFill>
+                      <a:prstDash val="solid"/>
+                      <a:round/>
+                      <a:headEnd type="none" w="med" len="med"/>
+                      <a:tailEnd type="none" w="med" len="med"/>
+                    </a:lnR>
+                    <a:lnT w="6350" cap="flat" cmpd="sng" algn="ctr">
+                      <a:solidFill>
+                        <a:srgbClr val="BBBBBB"/>
+                      </a:solidFill>
+                      <a:prstDash val="solid"/>
+                      <a:round/>
+                      <a:headEnd type="none" w="med" len="med"/>
+                      <a:tailEnd type="none" w="med" len="med"/>
+                    </a:lnT>
+                    <a:lnB w="6350" cap="flat" cmpd="sng" algn="ctr">
+                      <a:solidFill>
+                        <a:srgbClr val="BBBBBB"/>
+                      </a:solidFill>
+                      <a:prstDash val="solid"/>
+                      <a:round/>
+                      <a:headEnd type="none" w="med" len="med"/>
+                      <a:tailEnd type="none" w="med" len="med"/>
+                    </a:lnB>
+                  </a:tcPr>
+                </a:tc>
+                <a:tc>
+                  <a:txBody>
+                    <a:bodyPr/>
+                    <a:lstStyle/>
+                    <a:p>
+                      <a:pPr indent="0" marL="0">
+                        <a:buNone/>
+                      </a:pPr>
+                      <a:r>
+                        <a:rPr lang="en-US" sz="1100" b="1" dirty="0">
+                          <a:solidFill>
+                            <a:srgbClr val="222222"/>
+                          </a:solidFill>
+                          <a:latin typeface="游ゴシック" pitchFamily="34" charset="0"/>
+                          <a:ea typeface="游ゴシック" pitchFamily="34" charset="-122"/>
+                          <a:cs typeface="游ゴシック" pitchFamily="34" charset="-120"/>
+                        </a:rPr>
+                        <a:t>どちらが良いか</a:t>
+                      </a:r>
+                      <a:endParaRPr lang="en-US" sz="1100" dirty="0">
+                        <a:latin typeface="游ゴシック" charset="0"/>
+                        <a:ea typeface="游ゴシック" charset="0"/>
+                        <a:cs typeface="游ゴシック" charset="0"/>
+                      </a:endParaRPr>
+                    </a:p>
+                  </a:txBody>
+                  <a:tcPr marL="91440" marR="91440" marT="45720" marB="45720">
+                    <a:lnL w="6350" cap="flat" cmpd="sng" algn="ctr">
+                      <a:solidFill>
+                        <a:srgbClr val="BBBBBB"/>
+                      </a:solidFill>
+                      <a:prstDash val="solid"/>
+                      <a:round/>
+                      <a:headEnd type="none" w="med" len="med"/>
+                      <a:tailEnd type="none" w="med" len="med"/>
+                    </a:lnL>
+                    <a:lnR w="6350" cap="flat" cmpd="sng" algn="ctr">
+                      <a:solidFill>
+                        <a:srgbClr val="BBBBBB"/>
+                      </a:solidFill>
+                      <a:prstDash val="solid"/>
+                      <a:round/>
+                      <a:headEnd type="none" w="med" len="med"/>
+                      <a:tailEnd type="none" w="med" len="med"/>
+                    </a:lnR>
+                    <a:lnT w="6350" cap="flat" cmpd="sng" algn="ctr">
+                      <a:solidFill>
+                        <a:srgbClr val="BBBBBB"/>
+                      </a:solidFill>
+                      <a:prstDash val="solid"/>
+                      <a:round/>
+                      <a:headEnd type="none" w="med" len="med"/>
+                      <a:tailEnd type="none" w="med" len="med"/>
+                    </a:lnT>
+                    <a:lnB w="6350" cap="flat" cmpd="sng" algn="ctr">
+                      <a:solidFill>
+                        <a:srgbClr val="BBBBBB"/>
+                      </a:solidFill>
+                      <a:prstDash val="solid"/>
+                      <a:round/>
+                      <a:headEnd type="none" w="med" len="med"/>
+                      <a:tailEnd type="none" w="med" len="med"/>
+                    </a:lnB>
+                  </a:tcPr>
+                </a:tc>
+              </a:tr>
+              <a:tr h="365760">
+                <a:tc>
+                  <a:txBody>
+                    <a:bodyPr/>
+                    <a:lstStyle/>
+                    <a:p>
+                      <a:pPr indent="0" marL="0">
+                        <a:buNone/>
+                      </a:pPr>
+                      <a:r>
+                        <a:rPr lang="en-US" sz="1100" dirty="0">
+                          <a:solidFill>
+                            <a:srgbClr val="222222"/>
+                          </a:solidFill>
+                          <a:latin typeface="游ゴシック" pitchFamily="34" charset="0"/>
+                          <a:ea typeface="游ゴシック" pitchFamily="34" charset="-122"/>
+                          <a:cs typeface="游ゴシック" pitchFamily="34" charset="-120"/>
+                        </a:rPr>
+                        <a:t>施設を足したときの中村区の買物</a:t>
+                      </a:r>
+                      <a:endParaRPr lang="en-US" sz="1100" dirty="0">
+                        <a:latin typeface="游ゴシック" charset="0"/>
+                        <a:ea typeface="游ゴシック" charset="0"/>
+                        <a:cs typeface="游ゴシック" charset="0"/>
+                      </a:endParaRPr>
+                    </a:p>
+                  </a:txBody>
+                  <a:tcPr marL="91440" marR="91440" marT="45720" marB="45720">
+                    <a:lnL w="6350" cap="flat" cmpd="sng" algn="ctr">
+                      <a:solidFill>
+                        <a:srgbClr val="BBBBBB"/>
+                      </a:solidFill>
+                      <a:prstDash val="solid"/>
+                      <a:round/>
+                      <a:headEnd type="none" w="med" len="med"/>
+                      <a:tailEnd type="none" w="med" len="med"/>
+                    </a:lnL>
+                    <a:lnR w="6350" cap="flat" cmpd="sng" algn="ctr">
+                      <a:solidFill>
+                        <a:srgbClr val="BBBBBB"/>
+                      </a:solidFill>
+                      <a:prstDash val="solid"/>
+                      <a:round/>
+                      <a:headEnd type="none" w="med" len="med"/>
+                      <a:tailEnd type="none" w="med" len="med"/>
+                    </a:lnR>
+                    <a:lnT w="6350" cap="flat" cmpd="sng" algn="ctr">
+                      <a:solidFill>
+                        <a:srgbClr val="BBBBBB"/>
+                      </a:solidFill>
+                      <a:prstDash val="solid"/>
+                      <a:round/>
+                      <a:headEnd type="none" w="med" len="med"/>
+                      <a:tailEnd type="none" w="med" len="med"/>
+                    </a:lnT>
+                    <a:lnB w="6350" cap="flat" cmpd="sng" algn="ctr">
+                      <a:solidFill>
+                        <a:srgbClr val="BBBBBB"/>
+                      </a:solidFill>
+                      <a:prstDash val="solid"/>
+                      <a:round/>
+                      <a:headEnd type="none" w="med" len="med"/>
+                      <a:tailEnd type="none" w="med" len="med"/>
+                    </a:lnB>
+                  </a:tcPr>
+                </a:tc>
+                <a:tc>
+                  <a:txBody>
+                    <a:bodyPr/>
+                    <a:lstStyle/>
+                    <a:p>
+                      <a:pPr indent="0" marL="0">
+                        <a:buNone/>
+                      </a:pPr>
+                      <a:r>
+                        <a:rPr lang="en-US" sz="1100" dirty="0">
+                          <a:solidFill>
+                            <a:srgbClr val="222222"/>
+                          </a:solidFill>
+                          <a:latin typeface="游ゴシック" pitchFamily="34" charset="0"/>
+                          <a:ea typeface="游ゴシック" pitchFamily="34" charset="-122"/>
+                          <a:cs typeface="游ゴシック" pitchFamily="34" charset="-120"/>
+                        </a:rPr>
+                        <a:t>896→896（変化なし）</a:t>
+                      </a:r>
+                      <a:endParaRPr lang="en-US" sz="1100" dirty="0">
+                        <a:latin typeface="游ゴシック" charset="0"/>
+                        <a:ea typeface="游ゴシック" charset="0"/>
+                        <a:cs typeface="游ゴシック" charset="0"/>
+                      </a:endParaRPr>
+                    </a:p>
+                  </a:txBody>
+                  <a:tcPr marL="91440" marR="91440" marT="45720" marB="45720">
+                    <a:lnL w="6350" cap="flat" cmpd="sng" algn="ctr">
+                      <a:solidFill>
+                        <a:srgbClr val="BBBBBB"/>
+                      </a:solidFill>
+                      <a:prstDash val="solid"/>
+                      <a:round/>
+                      <a:headEnd type="none" w="med" len="med"/>
+                      <a:tailEnd type="none" w="med" len="med"/>
+                    </a:lnL>
+                    <a:lnR w="6350" cap="flat" cmpd="sng" algn="ctr">
+                      <a:solidFill>
+                        <a:srgbClr val="BBBBBB"/>
+                      </a:solidFill>
+                      <a:prstDash val="solid"/>
+                      <a:round/>
+                      <a:headEnd type="none" w="med" len="med"/>
+                      <a:tailEnd type="none" w="med" len="med"/>
+                    </a:lnR>
+                    <a:lnT w="6350" cap="flat" cmpd="sng" algn="ctr">
+                      <a:solidFill>
+                        <a:srgbClr val="BBBBBB"/>
+                      </a:solidFill>
+                      <a:prstDash val="solid"/>
+                      <a:round/>
+                      <a:headEnd type="none" w="med" len="med"/>
+                      <a:tailEnd type="none" w="med" len="med"/>
+                    </a:lnT>
+                    <a:lnB w="6350" cap="flat" cmpd="sng" algn="ctr">
+                      <a:solidFill>
+                        <a:srgbClr val="BBBBBB"/>
+                      </a:solidFill>
+                      <a:prstDash val="solid"/>
+                      <a:round/>
+                      <a:headEnd type="none" w="med" len="med"/>
+                      <a:tailEnd type="none" w="med" len="med"/>
+                    </a:lnB>
+                  </a:tcPr>
+                </a:tc>
+                <a:tc>
+                  <a:txBody>
+                    <a:bodyPr/>
+                    <a:lstStyle/>
+                    <a:p>
+                      <a:pPr indent="0" marL="0">
+                        <a:buNone/>
+                      </a:pPr>
+                      <a:r>
+                        <a:rPr lang="en-US" sz="1100" dirty="0">
+                          <a:solidFill>
+                            <a:srgbClr val="222222"/>
+                          </a:solidFill>
+                          <a:latin typeface="游ゴシック" pitchFamily="34" charset="0"/>
+                          <a:ea typeface="游ゴシック" pitchFamily="34" charset="-122"/>
+                          <a:cs typeface="游ゴシック" pitchFamily="34" charset="-120"/>
+                        </a:rPr>
+                        <a:t>+0.4%（全数）</a:t>
+                      </a:r>
+                      <a:endParaRPr lang="en-US" sz="1100" dirty="0">
+                        <a:latin typeface="游ゴシック" charset="0"/>
+                        <a:ea typeface="游ゴシック" charset="0"/>
+                        <a:cs typeface="游ゴシック" charset="0"/>
+                      </a:endParaRPr>
+                    </a:p>
+                  </a:txBody>
+                  <a:tcPr marL="91440" marR="91440" marT="45720" marB="45720">
+                    <a:lnL w="6350" cap="flat" cmpd="sng" algn="ctr">
+                      <a:solidFill>
+                        <a:srgbClr val="BBBBBB"/>
+                      </a:solidFill>
+                      <a:prstDash val="solid"/>
+                      <a:round/>
+                      <a:headEnd type="none" w="med" len="med"/>
+                      <a:tailEnd type="none" w="med" len="med"/>
+                    </a:lnL>
+                    <a:lnR w="6350" cap="flat" cmpd="sng" algn="ctr">
+                      <a:solidFill>
+                        <a:srgbClr val="BBBBBB"/>
+                      </a:solidFill>
+                      <a:prstDash val="solid"/>
+                      <a:round/>
+                      <a:headEnd type="none" w="med" len="med"/>
+                      <a:tailEnd type="none" w="med" len="med"/>
+                    </a:lnR>
+                    <a:lnT w="6350" cap="flat" cmpd="sng" algn="ctr">
+                      <a:solidFill>
+                        <a:srgbClr val="BBBBBB"/>
+                      </a:solidFill>
+                      <a:prstDash val="solid"/>
+                      <a:round/>
+                      <a:headEnd type="none" w="med" len="med"/>
+                      <a:tailEnd type="none" w="med" len="med"/>
+                    </a:lnT>
+                    <a:lnB w="6350" cap="flat" cmpd="sng" algn="ctr">
+                      <a:solidFill>
+                        <a:srgbClr val="BBBBBB"/>
+                      </a:solidFill>
+                      <a:prstDash val="solid"/>
+                      <a:round/>
+                      <a:headEnd type="none" w="med" len="med"/>
+                      <a:tailEnd type="none" w="med" len="med"/>
+                    </a:lnB>
+                  </a:tcPr>
+                </a:tc>
+                <a:tc>
+                  <a:txBody>
+                    <a:bodyPr/>
+                    <a:lstStyle/>
+                    <a:p>
+                      <a:pPr indent="0" marL="0">
+                        <a:buNone/>
+                      </a:pPr>
+                      <a:r>
+                        <a:rPr lang="en-US" sz="1100" dirty="0">
+                          <a:solidFill>
+                            <a:srgbClr val="222222"/>
+                          </a:solidFill>
+                          <a:latin typeface="游ゴシック" pitchFamily="34" charset="0"/>
+                          <a:ea typeface="游ゴシック" pitchFamily="34" charset="-122"/>
+                          <a:cs typeface="游ゴシック" pitchFamily="34" charset="-120"/>
+                        </a:rPr>
+                        <a:t>不明</a:t>
+                      </a:r>
+                      <a:endParaRPr lang="en-US" sz="1100" dirty="0">
+                        <a:latin typeface="游ゴシック" charset="0"/>
+                        <a:ea typeface="游ゴシック" charset="0"/>
+                        <a:cs typeface="游ゴシック" charset="0"/>
+                      </a:endParaRPr>
+                    </a:p>
+                  </a:txBody>
+                  <a:tcPr marL="91440" marR="91440" marT="45720" marB="45720">
+                    <a:lnL w="6350" cap="flat" cmpd="sng" algn="ctr">
+                      <a:solidFill>
+                        <a:srgbClr val="BBBBBB"/>
+                      </a:solidFill>
+                      <a:prstDash val="solid"/>
+                      <a:round/>
+                      <a:headEnd type="none" w="med" len="med"/>
+                      <a:tailEnd type="none" w="med" len="med"/>
+                    </a:lnL>
+                    <a:lnR w="6350" cap="flat" cmpd="sng" algn="ctr">
+                      <a:solidFill>
+                        <a:srgbClr val="BBBBBB"/>
+                      </a:solidFill>
+                      <a:prstDash val="solid"/>
+                      <a:round/>
+                      <a:headEnd type="none" w="med" len="med"/>
+                      <a:tailEnd type="none" w="med" len="med"/>
+                    </a:lnR>
+                    <a:lnT w="6350" cap="flat" cmpd="sng" algn="ctr">
+                      <a:solidFill>
+                        <a:srgbClr val="BBBBBB"/>
+                      </a:solidFill>
+                      <a:prstDash val="solid"/>
+                      <a:round/>
+                      <a:headEnd type="none" w="med" len="med"/>
+                      <a:tailEnd type="none" w="med" len="med"/>
+                    </a:lnT>
+                    <a:lnB w="6350" cap="flat" cmpd="sng" algn="ctr">
+                      <a:solidFill>
+                        <a:srgbClr val="BBBBBB"/>
+                      </a:solidFill>
+                      <a:prstDash val="solid"/>
+                      <a:round/>
+                      <a:headEnd type="none" w="med" len="med"/>
+                      <a:tailEnd type="none" w="med" len="med"/>
+                    </a:lnB>
+                  </a:tcPr>
+                </a:tc>
+                <a:tc>
+                  <a:txBody>
+                    <a:bodyPr/>
+                    <a:lstStyle/>
+                    <a:p>
+                      <a:pPr indent="0" marL="0">
+                        <a:buNone/>
+                      </a:pPr>
+                      <a:r>
+                        <a:rPr lang="en-US" sz="1100" b="1" dirty="0">
+                          <a:solidFill>
+                            <a:srgbClr val="1F6FB2"/>
+                          </a:solidFill>
+                          <a:latin typeface="游ゴシック" pitchFamily="34" charset="0"/>
+                          <a:ea typeface="游ゴシック" pitchFamily="34" charset="-122"/>
+                          <a:cs typeface="游ゴシック" pitchFamily="34" charset="-120"/>
+                        </a:rPr>
+                        <a:t>今回</a:t>
+                      </a:r>
+                      <a:endParaRPr lang="en-US" sz="1100" dirty="0">
+                        <a:latin typeface="游ゴシック" charset="0"/>
+                        <a:ea typeface="游ゴシック" charset="0"/>
+                        <a:cs typeface="游ゴシック" charset="0"/>
+                      </a:endParaRPr>
+                    </a:p>
+                  </a:txBody>
+                  <a:tcPr marL="91440" marR="91440" marT="45720" marB="45720">
+                    <a:lnL w="6350" cap="flat" cmpd="sng" algn="ctr">
+                      <a:solidFill>
+                        <a:srgbClr val="BBBBBB"/>
+                      </a:solidFill>
+                      <a:prstDash val="solid"/>
+                      <a:round/>
+                      <a:headEnd type="none" w="med" len="med"/>
+                      <a:tailEnd type="none" w="med" len="med"/>
+                    </a:lnL>
+                    <a:lnR w="6350" cap="flat" cmpd="sng" algn="ctr">
+                      <a:solidFill>
+                        <a:srgbClr val="BBBBBB"/>
+                      </a:solidFill>
+                      <a:prstDash val="solid"/>
+                      <a:round/>
+                      <a:headEnd type="none" w="med" len="med"/>
+                      <a:tailEnd type="none" w="med" len="med"/>
+                    </a:lnR>
+                    <a:lnT w="6350" cap="flat" cmpd="sng" algn="ctr">
+                      <a:solidFill>
+                        <a:srgbClr val="BBBBBB"/>
+                      </a:solidFill>
+                      <a:prstDash val="solid"/>
+                      <a:round/>
+                      <a:headEnd type="none" w="med" len="med"/>
+                      <a:tailEnd type="none" w="med" len="med"/>
+                    </a:lnT>
+                    <a:lnB w="6350" cap="flat" cmpd="sng" algn="ctr">
+                      <a:solidFill>
+                        <a:srgbClr val="BBBBBB"/>
+                      </a:solidFill>
+                      <a:prstDash val="solid"/>
+                      <a:round/>
+                      <a:headEnd type="none" w="med" len="med"/>
+                      <a:tailEnd type="none" w="med" len="med"/>
+                    </a:lnB>
+                  </a:tcPr>
+                </a:tc>
+              </a:tr>
+              <a:tr h="365760">
+                <a:tc>
+                  <a:txBody>
+                    <a:bodyPr/>
+                    <a:lstStyle/>
+                    <a:p>
+                      <a:pPr indent="0" marL="0">
+                        <a:buNone/>
+                      </a:pPr>
+                      <a:r>
+                        <a:rPr lang="en-US" sz="1100" dirty="0">
+                          <a:solidFill>
+                            <a:srgbClr val="222222"/>
+                          </a:solidFill>
+                          <a:latin typeface="游ゴシック" pitchFamily="34" charset="0"/>
+                          <a:ea typeface="游ゴシック" pitchFamily="34" charset="-122"/>
+                          <a:cs typeface="游ゴシック" pitchFamily="34" charset="-120"/>
+                        </a:rPr>
+                        <a:t>愛知全体の買物の行き先のずれ（TVD）</a:t>
+                      </a:r>
+                      <a:endParaRPr lang="en-US" sz="1100" dirty="0">
+                        <a:latin typeface="游ゴシック" charset="0"/>
+                        <a:ea typeface="游ゴシック" charset="0"/>
+                        <a:cs typeface="游ゴシック" charset="0"/>
+                      </a:endParaRPr>
+                    </a:p>
+                  </a:txBody>
+                  <a:tcPr marL="91440" marR="91440" marT="45720" marB="45720">
+                    <a:lnL w="6350" cap="flat" cmpd="sng" algn="ctr">
+                      <a:solidFill>
+                        <a:srgbClr val="BBBBBB"/>
+                      </a:solidFill>
+                      <a:prstDash val="solid"/>
+                      <a:round/>
+                      <a:headEnd type="none" w="med" len="med"/>
+                      <a:tailEnd type="none" w="med" len="med"/>
+                    </a:lnL>
+                    <a:lnR w="6350" cap="flat" cmpd="sng" algn="ctr">
+                      <a:solidFill>
+                        <a:srgbClr val="BBBBBB"/>
+                      </a:solidFill>
+                      <a:prstDash val="solid"/>
+                      <a:round/>
+                      <a:headEnd type="none" w="med" len="med"/>
+                      <a:tailEnd type="none" w="med" len="med"/>
+                    </a:lnR>
+                    <a:lnT w="6350" cap="flat" cmpd="sng" algn="ctr">
+                      <a:solidFill>
+                        <a:srgbClr val="BBBBBB"/>
+                      </a:solidFill>
+                      <a:prstDash val="solid"/>
+                      <a:round/>
+                      <a:headEnd type="none" w="med" len="med"/>
+                      <a:tailEnd type="none" w="med" len="med"/>
+                    </a:lnT>
+                    <a:lnB w="6350" cap="flat" cmpd="sng" algn="ctr">
+                      <a:solidFill>
+                        <a:srgbClr val="BBBBBB"/>
+                      </a:solidFill>
+                      <a:prstDash val="solid"/>
+                      <a:round/>
+                      <a:headEnd type="none" w="med" len="med"/>
+                      <a:tailEnd type="none" w="med" len="med"/>
+                    </a:lnB>
+                  </a:tcPr>
+                </a:tc>
+                <a:tc>
+                  <a:txBody>
+                    <a:bodyPr/>
+                    <a:lstStyle/>
+                    <a:p>
+                      <a:pPr indent="0" marL="0">
+                        <a:buNone/>
+                      </a:pPr>
+                      <a:r>
+                        <a:rPr lang="en-US" sz="1100" dirty="0">
+                          <a:solidFill>
+                            <a:srgbClr val="222222"/>
+                          </a:solidFill>
+                          <a:latin typeface="游ゴシック" pitchFamily="34" charset="0"/>
+                          <a:ea typeface="游ゴシック" pitchFamily="34" charset="-122"/>
+                          <a:cs typeface="游ゴシック" pitchFamily="34" charset="-120"/>
+                        </a:rPr>
+                        <a:t>0.138</a:t>
+                      </a:r>
+                      <a:endParaRPr lang="en-US" sz="1100" dirty="0">
+                        <a:latin typeface="游ゴシック" charset="0"/>
+                        <a:ea typeface="游ゴシック" charset="0"/>
+                        <a:cs typeface="游ゴシック" charset="0"/>
+                      </a:endParaRPr>
+                    </a:p>
+                  </a:txBody>
+                  <a:tcPr marL="91440" marR="91440" marT="45720" marB="45720">
+                    <a:lnL w="6350" cap="flat" cmpd="sng" algn="ctr">
+                      <a:solidFill>
+                        <a:srgbClr val="BBBBBB"/>
+                      </a:solidFill>
+                      <a:prstDash val="solid"/>
+                      <a:round/>
+                      <a:headEnd type="none" w="med" len="med"/>
+                      <a:tailEnd type="none" w="med" len="med"/>
+                    </a:lnL>
+                    <a:lnR w="6350" cap="flat" cmpd="sng" algn="ctr">
+                      <a:solidFill>
+                        <a:srgbClr val="BBBBBB"/>
+                      </a:solidFill>
+                      <a:prstDash val="solid"/>
+                      <a:round/>
+                      <a:headEnd type="none" w="med" len="med"/>
+                      <a:tailEnd type="none" w="med" len="med"/>
+                    </a:lnR>
+                    <a:lnT w="6350" cap="flat" cmpd="sng" algn="ctr">
+                      <a:solidFill>
+                        <a:srgbClr val="BBBBBB"/>
+                      </a:solidFill>
+                      <a:prstDash val="solid"/>
+                      <a:round/>
+                      <a:headEnd type="none" w="med" len="med"/>
+                      <a:tailEnd type="none" w="med" len="med"/>
+                    </a:lnT>
+                    <a:lnB w="6350" cap="flat" cmpd="sng" algn="ctr">
+                      <a:solidFill>
+                        <a:srgbClr val="BBBBBB"/>
+                      </a:solidFill>
+                      <a:prstDash val="solid"/>
+                      <a:round/>
+                      <a:headEnd type="none" w="med" len="med"/>
+                      <a:tailEnd type="none" w="med" len="med"/>
+                    </a:lnB>
+                  </a:tcPr>
+                </a:tc>
+                <a:tc>
+                  <a:txBody>
+                    <a:bodyPr/>
+                    <a:lstStyle/>
+                    <a:p>
+                      <a:pPr indent="0" marL="0">
+                        <a:buNone/>
+                      </a:pPr>
+                      <a:r>
+                        <a:rPr lang="en-US" sz="1100" dirty="0">
+                          <a:solidFill>
+                            <a:srgbClr val="222222"/>
+                          </a:solidFill>
+                          <a:latin typeface="游ゴシック" pitchFamily="34" charset="0"/>
+                          <a:ea typeface="游ゴシック" pitchFamily="34" charset="-122"/>
+                          <a:cs typeface="游ゴシック" pitchFamily="34" charset="-120"/>
+                        </a:rPr>
+                        <a:t>0.094</a:t>
+                      </a:r>
+                      <a:endParaRPr lang="en-US" sz="1100" dirty="0">
+                        <a:latin typeface="游ゴシック" charset="0"/>
+                        <a:ea typeface="游ゴシック" charset="0"/>
+                        <a:cs typeface="游ゴシック" charset="0"/>
+                      </a:endParaRPr>
+                    </a:p>
+                  </a:txBody>
+                  <a:tcPr marL="91440" marR="91440" marT="45720" marB="45720">
+                    <a:lnL w="6350" cap="flat" cmpd="sng" algn="ctr">
+                      <a:solidFill>
+                        <a:srgbClr val="BBBBBB"/>
+                      </a:solidFill>
+                      <a:prstDash val="solid"/>
+                      <a:round/>
+                      <a:headEnd type="none" w="med" len="med"/>
+                      <a:tailEnd type="none" w="med" len="med"/>
+                    </a:lnL>
+                    <a:lnR w="6350" cap="flat" cmpd="sng" algn="ctr">
+                      <a:solidFill>
+                        <a:srgbClr val="BBBBBB"/>
+                      </a:solidFill>
+                      <a:prstDash val="solid"/>
+                      <a:round/>
+                      <a:headEnd type="none" w="med" len="med"/>
+                      <a:tailEnd type="none" w="med" len="med"/>
+                    </a:lnR>
+                    <a:lnT w="6350" cap="flat" cmpd="sng" algn="ctr">
+                      <a:solidFill>
+                        <a:srgbClr val="BBBBBB"/>
+                      </a:solidFill>
+                      <a:prstDash val="solid"/>
+                      <a:round/>
+                      <a:headEnd type="none" w="med" len="med"/>
+                      <a:tailEnd type="none" w="med" len="med"/>
+                    </a:lnT>
+                    <a:lnB w="6350" cap="flat" cmpd="sng" algn="ctr">
+                      <a:solidFill>
+                        <a:srgbClr val="BBBBBB"/>
+                      </a:solidFill>
+                      <a:prstDash val="solid"/>
+                      <a:round/>
+                      <a:headEnd type="none" w="med" len="med"/>
+                      <a:tailEnd type="none" w="med" len="med"/>
+                    </a:lnB>
+                  </a:tcPr>
+                </a:tc>
+                <a:tc>
+                  <a:txBody>
+                    <a:bodyPr/>
+                    <a:lstStyle/>
+                    <a:p>
+                      <a:pPr indent="0" marL="0">
+                        <a:buNone/>
+                      </a:pPr>
+                      <a:r>
+                        <a:rPr lang="en-US" sz="1100" dirty="0">
+                          <a:solidFill>
+                            <a:srgbClr val="222222"/>
+                          </a:solidFill>
+                          <a:latin typeface="游ゴシック" pitchFamily="34" charset="0"/>
+                          <a:ea typeface="游ゴシック" pitchFamily="34" charset="-122"/>
+                          <a:cs typeface="游ゴシック" pitchFamily="34" charset="-120"/>
+                        </a:rPr>
+                        <a:t>0</a:t>
+                      </a:r>
+                      <a:endParaRPr lang="en-US" sz="1100" dirty="0">
+                        <a:latin typeface="游ゴシック" charset="0"/>
+                        <a:ea typeface="游ゴシック" charset="0"/>
+                        <a:cs typeface="游ゴシック" charset="0"/>
+                      </a:endParaRPr>
+                    </a:p>
+                  </a:txBody>
+                  <a:tcPr marL="91440" marR="91440" marT="45720" marB="45720">
+                    <a:lnL w="6350" cap="flat" cmpd="sng" algn="ctr">
+                      <a:solidFill>
+                        <a:srgbClr val="BBBBBB"/>
+                      </a:solidFill>
+                      <a:prstDash val="solid"/>
+                      <a:round/>
+                      <a:headEnd type="none" w="med" len="med"/>
+                      <a:tailEnd type="none" w="med" len="med"/>
+                    </a:lnL>
+                    <a:lnR w="6350" cap="flat" cmpd="sng" algn="ctr">
+                      <a:solidFill>
+                        <a:srgbClr val="BBBBBB"/>
+                      </a:solidFill>
+                      <a:prstDash val="solid"/>
+                      <a:round/>
+                      <a:headEnd type="none" w="med" len="med"/>
+                      <a:tailEnd type="none" w="med" len="med"/>
+                    </a:lnR>
+                    <a:lnT w="6350" cap="flat" cmpd="sng" algn="ctr">
+                      <a:solidFill>
+                        <a:srgbClr val="BBBBBB"/>
+                      </a:solidFill>
+                      <a:prstDash val="solid"/>
+                      <a:round/>
+                      <a:headEnd type="none" w="med" len="med"/>
+                      <a:tailEnd type="none" w="med" len="med"/>
+                    </a:lnT>
+                    <a:lnB w="6350" cap="flat" cmpd="sng" algn="ctr">
+                      <a:solidFill>
+                        <a:srgbClr val="BBBBBB"/>
+                      </a:solidFill>
+                      <a:prstDash val="solid"/>
+                      <a:round/>
+                      <a:headEnd type="none" w="med" len="med"/>
+                      <a:tailEnd type="none" w="med" len="med"/>
+                    </a:lnB>
+                  </a:tcPr>
+                </a:tc>
+                <a:tc>
+                  <a:txBody>
+                    <a:bodyPr/>
+                    <a:lstStyle/>
+                    <a:p>
+                      <a:pPr indent="0" marL="0">
+                        <a:buNone/>
+                      </a:pPr>
+                      <a:r>
+                        <a:rPr lang="en-US" sz="1100" b="1" dirty="0">
+                          <a:solidFill>
+                            <a:srgbClr val="1F6FB2"/>
+                          </a:solidFill>
+                          <a:latin typeface="游ゴシック" pitchFamily="34" charset="0"/>
+                          <a:ea typeface="游ゴシック" pitchFamily="34" charset="-122"/>
+                          <a:cs typeface="游ゴシック" pitchFamily="34" charset="-120"/>
+                        </a:rPr>
+                        <a:t>今回</a:t>
+                      </a:r>
+                      <a:endParaRPr lang="en-US" sz="1100" dirty="0">
+                        <a:latin typeface="游ゴシック" charset="0"/>
+                        <a:ea typeface="游ゴシック" charset="0"/>
+                        <a:cs typeface="游ゴシック" charset="0"/>
+                      </a:endParaRPr>
+                    </a:p>
+                  </a:txBody>
+                  <a:tcPr marL="91440" marR="91440" marT="45720" marB="45720">
+                    <a:lnL w="6350" cap="flat" cmpd="sng" algn="ctr">
+                      <a:solidFill>
+                        <a:srgbClr val="BBBBBB"/>
+                      </a:solidFill>
+                      <a:prstDash val="solid"/>
+                      <a:round/>
+                      <a:headEnd type="none" w="med" len="med"/>
+                      <a:tailEnd type="none" w="med" len="med"/>
+                    </a:lnL>
+                    <a:lnR w="6350" cap="flat" cmpd="sng" algn="ctr">
+                      <a:solidFill>
+                        <a:srgbClr val="BBBBBB"/>
+                      </a:solidFill>
+                      <a:prstDash val="solid"/>
+                      <a:round/>
+                      <a:headEnd type="none" w="med" len="med"/>
+                      <a:tailEnd type="none" w="med" len="med"/>
+                    </a:lnR>
+                    <a:lnT w="6350" cap="flat" cmpd="sng" algn="ctr">
+                      <a:solidFill>
+                        <a:srgbClr val="BBBBBB"/>
+                      </a:solidFill>
+                      <a:prstDash val="solid"/>
+                      <a:round/>
+                      <a:headEnd type="none" w="med" len="med"/>
+                      <a:tailEnd type="none" w="med" len="med"/>
+                    </a:lnT>
+                    <a:lnB w="6350" cap="flat" cmpd="sng" algn="ctr">
+                      <a:solidFill>
+                        <a:srgbClr val="BBBBBB"/>
+                      </a:solidFill>
+                      <a:prstDash val="solid"/>
+                      <a:round/>
+                      <a:headEnd type="none" w="med" len="med"/>
+                      <a:tailEnd type="none" w="med" len="med"/>
+                    </a:lnB>
+                  </a:tcPr>
+                </a:tc>
+              </a:tr>
+              <a:tr h="365760">
+                <a:tc>
+                  <a:txBody>
+                    <a:bodyPr/>
+                    <a:lstStyle/>
+                    <a:p>
+                      <a:pPr indent="0" marL="0">
+                        <a:buNone/>
+                      </a:pPr>
+                      <a:r>
+                        <a:rPr lang="en-US" sz="1100" dirty="0">
+                          <a:solidFill>
+                            <a:srgbClr val="222222"/>
+                          </a:solidFill>
+                          <a:latin typeface="游ゴシック" pitchFamily="34" charset="0"/>
+                          <a:ea typeface="游ゴシック" pitchFamily="34" charset="-122"/>
+                          <a:cs typeface="游ゴシック" pitchFamily="34" charset="-120"/>
+                        </a:rPr>
+                        <a:t>大型店以外の買物：未使用地区での当てはまり</a:t>
+                      </a:r>
+                      <a:endParaRPr lang="en-US" sz="1100" dirty="0">
+                        <a:latin typeface="游ゴシック" charset="0"/>
+                        <a:ea typeface="游ゴシック" charset="0"/>
+                        <a:cs typeface="游ゴシック" charset="0"/>
+                      </a:endParaRPr>
+                    </a:p>
+                  </a:txBody>
+                  <a:tcPr marL="91440" marR="91440" marT="45720" marB="45720">
+                    <a:lnL w="6350" cap="flat" cmpd="sng" algn="ctr">
+                      <a:solidFill>
+                        <a:srgbClr val="BBBBBB"/>
+                      </a:solidFill>
+                      <a:prstDash val="solid"/>
+                      <a:round/>
+                      <a:headEnd type="none" w="med" len="med"/>
+                      <a:tailEnd type="none" w="med" len="med"/>
+                    </a:lnL>
+                    <a:lnR w="6350" cap="flat" cmpd="sng" algn="ctr">
+                      <a:solidFill>
+                        <a:srgbClr val="BBBBBB"/>
+                      </a:solidFill>
+                      <a:prstDash val="solid"/>
+                      <a:round/>
+                      <a:headEnd type="none" w="med" len="med"/>
+                      <a:tailEnd type="none" w="med" len="med"/>
+                    </a:lnR>
+                    <a:lnT w="6350" cap="flat" cmpd="sng" algn="ctr">
+                      <a:solidFill>
+                        <a:srgbClr val="BBBBBB"/>
+                      </a:solidFill>
+                      <a:prstDash val="solid"/>
+                      <a:round/>
+                      <a:headEnd type="none" w="med" len="med"/>
+                      <a:tailEnd type="none" w="med" len="med"/>
+                    </a:lnT>
+                    <a:lnB w="6350" cap="flat" cmpd="sng" algn="ctr">
+                      <a:solidFill>
+                        <a:srgbClr val="BBBBBB"/>
+                      </a:solidFill>
+                      <a:prstDash val="solid"/>
+                      <a:round/>
+                      <a:headEnd type="none" w="med" len="med"/>
+                      <a:tailEnd type="none" w="med" len="med"/>
+                    </a:lnB>
+                  </a:tcPr>
+                </a:tc>
+                <a:tc>
+                  <a:txBody>
+                    <a:bodyPr/>
+                    <a:lstStyle/>
+                    <a:p>
+                      <a:pPr indent="0" marL="0">
+                        <a:buNone/>
+                      </a:pPr>
+                      <a:r>
+                        <a:rPr lang="en-US" sz="1100" dirty="0">
+                          <a:solidFill>
+                            <a:srgbClr val="222222"/>
+                          </a:solidFill>
+                          <a:latin typeface="游ゴシック" pitchFamily="34" charset="0"/>
+                          <a:ea typeface="游ゴシック" pitchFamily="34" charset="-122"/>
+                          <a:cs typeface="游ゴシック" pitchFamily="34" charset="-120"/>
+                        </a:rPr>
+                        <a:t>−1.247</a:t>
+                      </a:r>
+                      <a:endParaRPr lang="en-US" sz="1100" dirty="0">
+                        <a:latin typeface="游ゴシック" charset="0"/>
+                        <a:ea typeface="游ゴシック" charset="0"/>
+                        <a:cs typeface="游ゴシック" charset="0"/>
+                      </a:endParaRPr>
+                    </a:p>
+                  </a:txBody>
+                  <a:tcPr marL="91440" marR="91440" marT="45720" marB="45720">
+                    <a:lnL w="6350" cap="flat" cmpd="sng" algn="ctr">
+                      <a:solidFill>
+                        <a:srgbClr val="BBBBBB"/>
+                      </a:solidFill>
+                      <a:prstDash val="solid"/>
+                      <a:round/>
+                      <a:headEnd type="none" w="med" len="med"/>
+                      <a:tailEnd type="none" w="med" len="med"/>
+                    </a:lnL>
+                    <a:lnR w="6350" cap="flat" cmpd="sng" algn="ctr">
+                      <a:solidFill>
+                        <a:srgbClr val="BBBBBB"/>
+                      </a:solidFill>
+                      <a:prstDash val="solid"/>
+                      <a:round/>
+                      <a:headEnd type="none" w="med" len="med"/>
+                      <a:tailEnd type="none" w="med" len="med"/>
+                    </a:lnR>
+                    <a:lnT w="6350" cap="flat" cmpd="sng" algn="ctr">
+                      <a:solidFill>
+                        <a:srgbClr val="BBBBBB"/>
+                      </a:solidFill>
+                      <a:prstDash val="solid"/>
+                      <a:round/>
+                      <a:headEnd type="none" w="med" len="med"/>
+                      <a:tailEnd type="none" w="med" len="med"/>
+                    </a:lnT>
+                    <a:lnB w="6350" cap="flat" cmpd="sng" algn="ctr">
+                      <a:solidFill>
+                        <a:srgbClr val="BBBBBB"/>
+                      </a:solidFill>
+                      <a:prstDash val="solid"/>
+                      <a:round/>
+                      <a:headEnd type="none" w="med" len="med"/>
+                      <a:tailEnd type="none" w="med" len="med"/>
+                    </a:lnB>
+                  </a:tcPr>
+                </a:tc>
+                <a:tc>
+                  <a:txBody>
+                    <a:bodyPr/>
+                    <a:lstStyle/>
+                    <a:p>
+                      <a:pPr indent="0" marL="0">
+                        <a:buNone/>
+                      </a:pPr>
+                      <a:r>
+                        <a:rPr lang="en-US" sz="1100" dirty="0">
+                          <a:solidFill>
+                            <a:srgbClr val="222222"/>
+                          </a:solidFill>
+                          <a:latin typeface="游ゴシック" pitchFamily="34" charset="0"/>
+                          <a:ea typeface="游ゴシック" pitchFamily="34" charset="-122"/>
+                          <a:cs typeface="游ゴシック" pitchFamily="34" charset="-120"/>
+                        </a:rPr>
+                        <a:t>−1.230</a:t>
+                      </a:r>
+                      <a:endParaRPr lang="en-US" sz="1100" dirty="0">
+                        <a:latin typeface="游ゴシック" charset="0"/>
+                        <a:ea typeface="游ゴシック" charset="0"/>
+                        <a:cs typeface="游ゴシック" charset="0"/>
+                      </a:endParaRPr>
+                    </a:p>
+                  </a:txBody>
+                  <a:tcPr marL="91440" marR="91440" marT="45720" marB="45720">
+                    <a:lnL w="6350" cap="flat" cmpd="sng" algn="ctr">
+                      <a:solidFill>
+                        <a:srgbClr val="BBBBBB"/>
+                      </a:solidFill>
+                      <a:prstDash val="solid"/>
+                      <a:round/>
+                      <a:headEnd type="none" w="med" len="med"/>
+                      <a:tailEnd type="none" w="med" len="med"/>
+                    </a:lnL>
+                    <a:lnR w="6350" cap="flat" cmpd="sng" algn="ctr">
+                      <a:solidFill>
+                        <a:srgbClr val="BBBBBB"/>
+                      </a:solidFill>
+                      <a:prstDash val="solid"/>
+                      <a:round/>
+                      <a:headEnd type="none" w="med" len="med"/>
+                      <a:tailEnd type="none" w="med" len="med"/>
+                    </a:lnR>
+                    <a:lnT w="6350" cap="flat" cmpd="sng" algn="ctr">
+                      <a:solidFill>
+                        <a:srgbClr val="BBBBBB"/>
+                      </a:solidFill>
+                      <a:prstDash val="solid"/>
+                      <a:round/>
+                      <a:headEnd type="none" w="med" len="med"/>
+                      <a:tailEnd type="none" w="med" len="med"/>
+                    </a:lnT>
+                    <a:lnB w="6350" cap="flat" cmpd="sng" algn="ctr">
+                      <a:solidFill>
+                        <a:srgbClr val="BBBBBB"/>
+                      </a:solidFill>
+                      <a:prstDash val="solid"/>
+                      <a:round/>
+                      <a:headEnd type="none" w="med" len="med"/>
+                      <a:tailEnd type="none" w="med" len="med"/>
+                    </a:lnB>
+                  </a:tcPr>
+                </a:tc>
+                <a:tc>
+                  <a:txBody>
+                    <a:bodyPr/>
+                    <a:lstStyle/>
+                    <a:p>
+                      <a:pPr indent="0" marL="0">
+                        <a:buNone/>
+                      </a:pPr>
+                      <a:r>
+                        <a:rPr lang="en-US" sz="1100" dirty="0">
+                          <a:solidFill>
+                            <a:srgbClr val="222222"/>
+                          </a:solidFill>
+                          <a:latin typeface="游ゴシック" pitchFamily="34" charset="0"/>
+                          <a:ea typeface="游ゴシック" pitchFamily="34" charset="-122"/>
+                          <a:cs typeface="游ゴシック" pitchFamily="34" charset="-120"/>
+                        </a:rPr>
+                        <a:t>大きい方が良</a:t>
+                      </a:r>
+                      <a:endParaRPr lang="en-US" sz="1100" dirty="0">
+                        <a:latin typeface="游ゴシック" charset="0"/>
+                        <a:ea typeface="游ゴシック" charset="0"/>
+                        <a:cs typeface="游ゴシック" charset="0"/>
+                      </a:endParaRPr>
+                    </a:p>
+                  </a:txBody>
+                  <a:tcPr marL="91440" marR="91440" marT="45720" marB="45720">
+                    <a:lnL w="6350" cap="flat" cmpd="sng" algn="ctr">
+                      <a:solidFill>
+                        <a:srgbClr val="BBBBBB"/>
+                      </a:solidFill>
+                      <a:prstDash val="solid"/>
+                      <a:round/>
+                      <a:headEnd type="none" w="med" len="med"/>
+                      <a:tailEnd type="none" w="med" len="med"/>
+                    </a:lnL>
+                    <a:lnR w="6350" cap="flat" cmpd="sng" algn="ctr">
+                      <a:solidFill>
+                        <a:srgbClr val="BBBBBB"/>
+                      </a:solidFill>
+                      <a:prstDash val="solid"/>
+                      <a:round/>
+                      <a:headEnd type="none" w="med" len="med"/>
+                      <a:tailEnd type="none" w="med" len="med"/>
+                    </a:lnR>
+                    <a:lnT w="6350" cap="flat" cmpd="sng" algn="ctr">
+                      <a:solidFill>
+                        <a:srgbClr val="BBBBBB"/>
+                      </a:solidFill>
+                      <a:prstDash val="solid"/>
+                      <a:round/>
+                      <a:headEnd type="none" w="med" len="med"/>
+                      <a:tailEnd type="none" w="med" len="med"/>
+                    </a:lnT>
+                    <a:lnB w="6350" cap="flat" cmpd="sng" algn="ctr">
+                      <a:solidFill>
+                        <a:srgbClr val="BBBBBB"/>
+                      </a:solidFill>
+                      <a:prstDash val="solid"/>
+                      <a:round/>
+                      <a:headEnd type="none" w="med" len="med"/>
+                      <a:tailEnd type="none" w="med" len="med"/>
+                    </a:lnB>
+                  </a:tcPr>
+                </a:tc>
+                <a:tc>
+                  <a:txBody>
+                    <a:bodyPr/>
+                    <a:lstStyle/>
+                    <a:p>
+                      <a:pPr indent="0" marL="0">
+                        <a:buNone/>
+                      </a:pPr>
+                      <a:r>
+                        <a:rPr lang="en-US" sz="1100" b="1" dirty="0">
+                          <a:solidFill>
+                            <a:srgbClr val="1F6FB2"/>
+                          </a:solidFill>
+                          <a:latin typeface="游ゴシック" pitchFamily="34" charset="0"/>
+                          <a:ea typeface="游ゴシック" pitchFamily="34" charset="-122"/>
+                          <a:cs typeface="游ゴシック" pitchFamily="34" charset="-120"/>
+                        </a:rPr>
+                        <a:t>今回（僅差）</a:t>
+                      </a:r>
+                      <a:endParaRPr lang="en-US" sz="1100" dirty="0">
+                        <a:latin typeface="游ゴシック" charset="0"/>
+                        <a:ea typeface="游ゴシック" charset="0"/>
+                        <a:cs typeface="游ゴシック" charset="0"/>
+                      </a:endParaRPr>
+                    </a:p>
+                  </a:txBody>
+                  <a:tcPr marL="91440" marR="91440" marT="45720" marB="45720">
+                    <a:lnL w="6350" cap="flat" cmpd="sng" algn="ctr">
+                      <a:solidFill>
+                        <a:srgbClr val="BBBBBB"/>
+                      </a:solidFill>
+                      <a:prstDash val="solid"/>
+                      <a:round/>
+                      <a:headEnd type="none" w="med" len="med"/>
+                      <a:tailEnd type="none" w="med" len="med"/>
+                    </a:lnL>
+                    <a:lnR w="6350" cap="flat" cmpd="sng" algn="ctr">
+                      <a:solidFill>
+                        <a:srgbClr val="BBBBBB"/>
+                      </a:solidFill>
+                      <a:prstDash val="solid"/>
+                      <a:round/>
+                      <a:headEnd type="none" w="med" len="med"/>
+                      <a:tailEnd type="none" w="med" len="med"/>
+                    </a:lnR>
+                    <a:lnT w="6350" cap="flat" cmpd="sng" algn="ctr">
+                      <a:solidFill>
+                        <a:srgbClr val="BBBBBB"/>
+                      </a:solidFill>
+                      <a:prstDash val="solid"/>
+                      <a:round/>
+                      <a:headEnd type="none" w="med" len="med"/>
+                      <a:tailEnd type="none" w="med" len="med"/>
+                    </a:lnT>
+                    <a:lnB w="6350" cap="flat" cmpd="sng" algn="ctr">
+                      <a:solidFill>
+                        <a:srgbClr val="BBBBBB"/>
+                      </a:solidFill>
+                      <a:prstDash val="solid"/>
+                      <a:round/>
+                      <a:headEnd type="none" w="med" len="med"/>
+                      <a:tailEnd type="none" w="med" len="med"/>
+                    </a:lnB>
+                  </a:tcPr>
+                </a:tc>
+              </a:tr>
+              <a:tr h="365760">
+                <a:tc>
+                  <a:txBody>
+                    <a:bodyPr/>
+                    <a:lstStyle/>
+                    <a:p>
+                      <a:pPr indent="0" marL="0">
+                        <a:buNone/>
+                      </a:pPr>
+                      <a:r>
+                        <a:rPr lang="en-US" sz="1100" dirty="0">
+                          <a:solidFill>
+                            <a:srgbClr val="222222"/>
+                          </a:solidFill>
+                          <a:latin typeface="游ゴシック" pitchFamily="34" charset="0"/>
+                          <a:ea typeface="游ゴシック" pitchFamily="34" charset="-122"/>
+                          <a:cs typeface="游ゴシック" pitchFamily="34" charset="-120"/>
+                        </a:rPr>
+                        <a:t>愛知全体で同じ地区内に買物に行く割合</a:t>
+                      </a:r>
+                      <a:endParaRPr lang="en-US" sz="1100" dirty="0">
+                        <a:latin typeface="游ゴシック" charset="0"/>
+                        <a:ea typeface="游ゴシック" charset="0"/>
+                        <a:cs typeface="游ゴシック" charset="0"/>
+                      </a:endParaRPr>
+                    </a:p>
+                  </a:txBody>
+                  <a:tcPr marL="91440" marR="91440" marT="45720" marB="45720">
+                    <a:lnL w="6350" cap="flat" cmpd="sng" algn="ctr">
+                      <a:solidFill>
+                        <a:srgbClr val="BBBBBB"/>
+                      </a:solidFill>
+                      <a:prstDash val="solid"/>
+                      <a:round/>
+                      <a:headEnd type="none" w="med" len="med"/>
+                      <a:tailEnd type="none" w="med" len="med"/>
+                    </a:lnL>
+                    <a:lnR w="6350" cap="flat" cmpd="sng" algn="ctr">
+                      <a:solidFill>
+                        <a:srgbClr val="BBBBBB"/>
+                      </a:solidFill>
+                      <a:prstDash val="solid"/>
+                      <a:round/>
+                      <a:headEnd type="none" w="med" len="med"/>
+                      <a:tailEnd type="none" w="med" len="med"/>
+                    </a:lnR>
+                    <a:lnT w="6350" cap="flat" cmpd="sng" algn="ctr">
+                      <a:solidFill>
+                        <a:srgbClr val="BBBBBB"/>
+                      </a:solidFill>
+                      <a:prstDash val="solid"/>
+                      <a:round/>
+                      <a:headEnd type="none" w="med" len="med"/>
+                      <a:tailEnd type="none" w="med" len="med"/>
+                    </a:lnT>
+                    <a:lnB w="6350" cap="flat" cmpd="sng" algn="ctr">
+                      <a:solidFill>
+                        <a:srgbClr val="BBBBBB"/>
+                      </a:solidFill>
+                      <a:prstDash val="solid"/>
+                      <a:round/>
+                      <a:headEnd type="none" w="med" len="med"/>
+                      <a:tailEnd type="none" w="med" len="med"/>
+                    </a:lnB>
+                  </a:tcPr>
+                </a:tc>
+                <a:tc>
+                  <a:txBody>
+                    <a:bodyPr/>
+                    <a:lstStyle/>
+                    <a:p>
+                      <a:pPr indent="0" marL="0">
+                        <a:buNone/>
+                      </a:pPr>
+                      <a:r>
+                        <a:rPr lang="en-US" sz="1100" dirty="0">
+                          <a:solidFill>
+                            <a:srgbClr val="222222"/>
+                          </a:solidFill>
+                          <a:latin typeface="游ゴシック" pitchFamily="34" charset="0"/>
+                          <a:ea typeface="游ゴシック" pitchFamily="34" charset="-122"/>
+                          <a:cs typeface="游ゴシック" pitchFamily="34" charset="-120"/>
+                        </a:rPr>
+                        <a:t>0.704</a:t>
+                      </a:r>
+                      <a:endParaRPr lang="en-US" sz="1100" dirty="0">
+                        <a:latin typeface="游ゴシック" charset="0"/>
+                        <a:ea typeface="游ゴシック" charset="0"/>
+                        <a:cs typeface="游ゴシック" charset="0"/>
+                      </a:endParaRPr>
+                    </a:p>
+                  </a:txBody>
+                  <a:tcPr marL="91440" marR="91440" marT="45720" marB="45720">
+                    <a:lnL w="6350" cap="flat" cmpd="sng" algn="ctr">
+                      <a:solidFill>
+                        <a:srgbClr val="BBBBBB"/>
+                      </a:solidFill>
+                      <a:prstDash val="solid"/>
+                      <a:round/>
+                      <a:headEnd type="none" w="med" len="med"/>
+                      <a:tailEnd type="none" w="med" len="med"/>
+                    </a:lnL>
+                    <a:lnR w="6350" cap="flat" cmpd="sng" algn="ctr">
+                      <a:solidFill>
+                        <a:srgbClr val="BBBBBB"/>
+                      </a:solidFill>
+                      <a:prstDash val="solid"/>
+                      <a:round/>
+                      <a:headEnd type="none" w="med" len="med"/>
+                      <a:tailEnd type="none" w="med" len="med"/>
+                    </a:lnR>
+                    <a:lnT w="6350" cap="flat" cmpd="sng" algn="ctr">
+                      <a:solidFill>
+                        <a:srgbClr val="BBBBBB"/>
+                      </a:solidFill>
+                      <a:prstDash val="solid"/>
+                      <a:round/>
+                      <a:headEnd type="none" w="med" len="med"/>
+                      <a:tailEnd type="none" w="med" len="med"/>
+                    </a:lnT>
+                    <a:lnB w="6350" cap="flat" cmpd="sng" algn="ctr">
+                      <a:solidFill>
+                        <a:srgbClr val="BBBBBB"/>
+                      </a:solidFill>
+                      <a:prstDash val="solid"/>
+                      <a:round/>
+                      <a:headEnd type="none" w="med" len="med"/>
+                      <a:tailEnd type="none" w="med" len="med"/>
+                    </a:lnB>
+                  </a:tcPr>
+                </a:tc>
+                <a:tc>
+                  <a:txBody>
+                    <a:bodyPr/>
+                    <a:lstStyle/>
+                    <a:p>
+                      <a:pPr indent="0" marL="0">
+                        <a:buNone/>
+                      </a:pPr>
+                      <a:r>
+                        <a:rPr lang="en-US" sz="1100" dirty="0">
+                          <a:solidFill>
+                            <a:srgbClr val="222222"/>
+                          </a:solidFill>
+                          <a:latin typeface="游ゴシック" pitchFamily="34" charset="0"/>
+                          <a:ea typeface="游ゴシック" pitchFamily="34" charset="-122"/>
+                          <a:cs typeface="游ゴシック" pitchFamily="34" charset="-120"/>
+                        </a:rPr>
+                        <a:t>0.621</a:t>
+                      </a:r>
+                      <a:endParaRPr lang="en-US" sz="1100" dirty="0">
+                        <a:latin typeface="游ゴシック" charset="0"/>
+                        <a:ea typeface="游ゴシック" charset="0"/>
+                        <a:cs typeface="游ゴシック" charset="0"/>
+                      </a:endParaRPr>
+                    </a:p>
+                  </a:txBody>
+                  <a:tcPr marL="91440" marR="91440" marT="45720" marB="45720">
+                    <a:lnL w="6350" cap="flat" cmpd="sng" algn="ctr">
+                      <a:solidFill>
+                        <a:srgbClr val="BBBBBB"/>
+                      </a:solidFill>
+                      <a:prstDash val="solid"/>
+                      <a:round/>
+                      <a:headEnd type="none" w="med" len="med"/>
+                      <a:tailEnd type="none" w="med" len="med"/>
+                    </a:lnL>
+                    <a:lnR w="6350" cap="flat" cmpd="sng" algn="ctr">
+                      <a:solidFill>
+                        <a:srgbClr val="BBBBBB"/>
+                      </a:solidFill>
+                      <a:prstDash val="solid"/>
+                      <a:round/>
+                      <a:headEnd type="none" w="med" len="med"/>
+                      <a:tailEnd type="none" w="med" len="med"/>
+                    </a:lnR>
+                    <a:lnT w="6350" cap="flat" cmpd="sng" algn="ctr">
+                      <a:solidFill>
+                        <a:srgbClr val="BBBBBB"/>
+                      </a:solidFill>
+                      <a:prstDash val="solid"/>
+                      <a:round/>
+                      <a:headEnd type="none" w="med" len="med"/>
+                      <a:tailEnd type="none" w="med" len="med"/>
+                    </a:lnT>
+                    <a:lnB w="6350" cap="flat" cmpd="sng" algn="ctr">
+                      <a:solidFill>
+                        <a:srgbClr val="BBBBBB"/>
+                      </a:solidFill>
+                      <a:prstDash val="solid"/>
+                      <a:round/>
+                      <a:headEnd type="none" w="med" len="med"/>
+                      <a:tailEnd type="none" w="med" len="med"/>
+                    </a:lnB>
+                  </a:tcPr>
+                </a:tc>
+                <a:tc>
+                  <a:txBody>
+                    <a:bodyPr/>
+                    <a:lstStyle/>
+                    <a:p>
+                      <a:pPr indent="0" marL="0">
+                        <a:buNone/>
+                      </a:pPr>
+                      <a:r>
+                        <a:rPr lang="en-US" sz="1100" dirty="0">
+                          <a:solidFill>
+                            <a:srgbClr val="222222"/>
+                          </a:solidFill>
+                          <a:latin typeface="游ゴシック" pitchFamily="34" charset="0"/>
+                          <a:ea typeface="游ゴシック" pitchFamily="34" charset="-122"/>
+                          <a:cs typeface="游ゴシック" pitchFamily="34" charset="-120"/>
+                        </a:rPr>
+                        <a:t>0.707</a:t>
+                      </a:r>
+                      <a:endParaRPr lang="en-US" sz="1100" dirty="0">
+                        <a:latin typeface="游ゴシック" charset="0"/>
+                        <a:ea typeface="游ゴシック" charset="0"/>
+                        <a:cs typeface="游ゴシック" charset="0"/>
+                      </a:endParaRPr>
+                    </a:p>
+                  </a:txBody>
+                  <a:tcPr marL="91440" marR="91440" marT="45720" marB="45720">
+                    <a:lnL w="6350" cap="flat" cmpd="sng" algn="ctr">
+                      <a:solidFill>
+                        <a:srgbClr val="BBBBBB"/>
+                      </a:solidFill>
+                      <a:prstDash val="solid"/>
+                      <a:round/>
+                      <a:headEnd type="none" w="med" len="med"/>
+                      <a:tailEnd type="none" w="med" len="med"/>
+                    </a:lnL>
+                    <a:lnR w="6350" cap="flat" cmpd="sng" algn="ctr">
+                      <a:solidFill>
+                        <a:srgbClr val="BBBBBB"/>
+                      </a:solidFill>
+                      <a:prstDash val="solid"/>
+                      <a:round/>
+                      <a:headEnd type="none" w="med" len="med"/>
+                      <a:tailEnd type="none" w="med" len="med"/>
+                    </a:lnR>
+                    <a:lnT w="6350" cap="flat" cmpd="sng" algn="ctr">
+                      <a:solidFill>
+                        <a:srgbClr val="BBBBBB"/>
+                      </a:solidFill>
+                      <a:prstDash val="solid"/>
+                      <a:round/>
+                      <a:headEnd type="none" w="med" len="med"/>
+                      <a:tailEnd type="none" w="med" len="med"/>
+                    </a:lnT>
+                    <a:lnB w="6350" cap="flat" cmpd="sng" algn="ctr">
+                      <a:solidFill>
+                        <a:srgbClr val="BBBBBB"/>
+                      </a:solidFill>
+                      <a:prstDash val="solid"/>
+                      <a:round/>
+                      <a:headEnd type="none" w="med" len="med"/>
+                      <a:tailEnd type="none" w="med" len="med"/>
+                    </a:lnB>
+                  </a:tcPr>
+                </a:tc>
+                <a:tc>
+                  <a:txBody>
+                    <a:bodyPr/>
+                    <a:lstStyle/>
+                    <a:p>
+                      <a:pPr indent="0" marL="0">
+                        <a:buNone/>
+                      </a:pPr>
+                      <a:r>
+                        <a:rPr lang="en-US" sz="1100" b="1" dirty="0">
+                          <a:solidFill>
+                            <a:srgbClr val="C0504D"/>
+                          </a:solidFill>
+                          <a:latin typeface="游ゴシック" pitchFamily="34" charset="0"/>
+                          <a:ea typeface="游ゴシック" pitchFamily="34" charset="-122"/>
+                          <a:cs typeface="游ゴシック" pitchFamily="34" charset="-120"/>
+                        </a:rPr>
+                        <a:t>研究室</a:t>
+                      </a:r>
+                      <a:endParaRPr lang="en-US" sz="1100" dirty="0">
+                        <a:latin typeface="游ゴシック" charset="0"/>
+                        <a:ea typeface="游ゴシック" charset="0"/>
+                        <a:cs typeface="游ゴシック" charset="0"/>
+                      </a:endParaRPr>
+                    </a:p>
+                  </a:txBody>
+                  <a:tcPr marL="91440" marR="91440" marT="45720" marB="45720">
+                    <a:lnL w="6350" cap="flat" cmpd="sng" algn="ctr">
+                      <a:solidFill>
+                        <a:srgbClr val="BBBBBB"/>
+                      </a:solidFill>
+                      <a:prstDash val="solid"/>
+                      <a:round/>
+                      <a:headEnd type="none" w="med" len="med"/>
+                      <a:tailEnd type="none" w="med" len="med"/>
+                    </a:lnL>
+                    <a:lnR w="6350" cap="flat" cmpd="sng" algn="ctr">
+                      <a:solidFill>
+                        <a:srgbClr val="BBBBBB"/>
+                      </a:solidFill>
+                      <a:prstDash val="solid"/>
+                      <a:round/>
+                      <a:headEnd type="none" w="med" len="med"/>
+                      <a:tailEnd type="none" w="med" len="med"/>
+                    </a:lnR>
+                    <a:lnT w="6350" cap="flat" cmpd="sng" algn="ctr">
+                      <a:solidFill>
+                        <a:srgbClr val="BBBBBB"/>
+                      </a:solidFill>
+                      <a:prstDash val="solid"/>
+                      <a:round/>
+                      <a:headEnd type="none" w="med" len="med"/>
+                      <a:tailEnd type="none" w="med" len="med"/>
+                    </a:lnT>
+                    <a:lnB w="6350" cap="flat" cmpd="sng" algn="ctr">
+                      <a:solidFill>
+                        <a:srgbClr val="BBBBBB"/>
+                      </a:solidFill>
+                      <a:prstDash val="solid"/>
+                      <a:round/>
+                      <a:headEnd type="none" w="med" len="med"/>
+                      <a:tailEnd type="none" w="med" len="med"/>
+                    </a:lnB>
+                  </a:tcPr>
+                </a:tc>
+              </a:tr>
+              <a:tr h="365760">
+                <a:tc>
+                  <a:txBody>
+                    <a:bodyPr/>
+                    <a:lstStyle/>
+                    <a:p>
+                      <a:pPr indent="0" marL="0">
+                        <a:buNone/>
+                      </a:pPr>
+                      <a:r>
+                        <a:rPr lang="en-US" sz="1100" dirty="0">
+                          <a:solidFill>
+                            <a:srgbClr val="222222"/>
+                          </a:solidFill>
+                          <a:latin typeface="游ゴシック" pitchFamily="34" charset="0"/>
+                          <a:ea typeface="游ゴシック" pitchFamily="34" charset="-122"/>
+                          <a:cs typeface="游ゴシック" pitchFamily="34" charset="-120"/>
+                        </a:rPr>
+                        <a:t>中村区に来る買物全体の出発地のずれ</a:t>
+                      </a:r>
+                      <a:endParaRPr lang="en-US" sz="1100" dirty="0">
+                        <a:latin typeface="游ゴシック" charset="0"/>
+                        <a:ea typeface="游ゴシック" charset="0"/>
+                        <a:cs typeface="游ゴシック" charset="0"/>
+                      </a:endParaRPr>
+                    </a:p>
+                  </a:txBody>
+                  <a:tcPr marL="91440" marR="91440" marT="45720" marB="45720">
+                    <a:lnL w="6350" cap="flat" cmpd="sng" algn="ctr">
+                      <a:solidFill>
+                        <a:srgbClr val="BBBBBB"/>
+                      </a:solidFill>
+                      <a:prstDash val="solid"/>
+                      <a:round/>
+                      <a:headEnd type="none" w="med" len="med"/>
+                      <a:tailEnd type="none" w="med" len="med"/>
+                    </a:lnL>
+                    <a:lnR w="6350" cap="flat" cmpd="sng" algn="ctr">
+                      <a:solidFill>
+                        <a:srgbClr val="BBBBBB"/>
+                      </a:solidFill>
+                      <a:prstDash val="solid"/>
+                      <a:round/>
+                      <a:headEnd type="none" w="med" len="med"/>
+                      <a:tailEnd type="none" w="med" len="med"/>
+                    </a:lnR>
+                    <a:lnT w="6350" cap="flat" cmpd="sng" algn="ctr">
+                      <a:solidFill>
+                        <a:srgbClr val="BBBBBB"/>
+                      </a:solidFill>
+                      <a:prstDash val="solid"/>
+                      <a:round/>
+                      <a:headEnd type="none" w="med" len="med"/>
+                      <a:tailEnd type="none" w="med" len="med"/>
+                    </a:lnT>
+                    <a:lnB w="6350" cap="flat" cmpd="sng" algn="ctr">
+                      <a:solidFill>
+                        <a:srgbClr val="BBBBBB"/>
+                      </a:solidFill>
+                      <a:prstDash val="solid"/>
+                      <a:round/>
+                      <a:headEnd type="none" w="med" len="med"/>
+                      <a:tailEnd type="none" w="med" len="med"/>
+                    </a:lnB>
+                  </a:tcPr>
+                </a:tc>
+                <a:tc>
+                  <a:txBody>
+                    <a:bodyPr/>
+                    <a:lstStyle/>
+                    <a:p>
+                      <a:pPr indent="0" marL="0">
+                        <a:buNone/>
+                      </a:pPr>
+                      <a:r>
+                        <a:rPr lang="en-US" sz="1100" dirty="0">
+                          <a:solidFill>
+                            <a:srgbClr val="222222"/>
+                          </a:solidFill>
+                          <a:latin typeface="游ゴシック" pitchFamily="34" charset="0"/>
+                          <a:ea typeface="游ゴシック" pitchFamily="34" charset="-122"/>
+                          <a:cs typeface="游ゴシック" pitchFamily="34" charset="-120"/>
+                        </a:rPr>
+                        <a:t>0.246</a:t>
+                      </a:r>
+                      <a:endParaRPr lang="en-US" sz="1100" dirty="0">
+                        <a:latin typeface="游ゴシック" charset="0"/>
+                        <a:ea typeface="游ゴシック" charset="0"/>
+                        <a:cs typeface="游ゴシック" charset="0"/>
+                      </a:endParaRPr>
+                    </a:p>
+                  </a:txBody>
+                  <a:tcPr marL="91440" marR="91440" marT="45720" marB="45720">
+                    <a:lnL w="6350" cap="flat" cmpd="sng" algn="ctr">
+                      <a:solidFill>
+                        <a:srgbClr val="BBBBBB"/>
+                      </a:solidFill>
+                      <a:prstDash val="solid"/>
+                      <a:round/>
+                      <a:headEnd type="none" w="med" len="med"/>
+                      <a:tailEnd type="none" w="med" len="med"/>
+                    </a:lnL>
+                    <a:lnR w="6350" cap="flat" cmpd="sng" algn="ctr">
+                      <a:solidFill>
+                        <a:srgbClr val="BBBBBB"/>
+                      </a:solidFill>
+                      <a:prstDash val="solid"/>
+                      <a:round/>
+                      <a:headEnd type="none" w="med" len="med"/>
+                      <a:tailEnd type="none" w="med" len="med"/>
+                    </a:lnR>
+                    <a:lnT w="6350" cap="flat" cmpd="sng" algn="ctr">
+                      <a:solidFill>
+                        <a:srgbClr val="BBBBBB"/>
+                      </a:solidFill>
+                      <a:prstDash val="solid"/>
+                      <a:round/>
+                      <a:headEnd type="none" w="med" len="med"/>
+                      <a:tailEnd type="none" w="med" len="med"/>
+                    </a:lnT>
+                    <a:lnB w="6350" cap="flat" cmpd="sng" algn="ctr">
+                      <a:solidFill>
+                        <a:srgbClr val="BBBBBB"/>
+                      </a:solidFill>
+                      <a:prstDash val="solid"/>
+                      <a:round/>
+                      <a:headEnd type="none" w="med" len="med"/>
+                      <a:tailEnd type="none" w="med" len="med"/>
+                    </a:lnB>
+                  </a:tcPr>
+                </a:tc>
+                <a:tc>
+                  <a:txBody>
+                    <a:bodyPr/>
+                    <a:lstStyle/>
+                    <a:p>
+                      <a:pPr indent="0" marL="0">
+                        <a:buNone/>
+                      </a:pPr>
+                      <a:r>
+                        <a:rPr lang="en-US" sz="1100" dirty="0">
+                          <a:solidFill>
+                            <a:srgbClr val="222222"/>
+                          </a:solidFill>
+                          <a:latin typeface="游ゴシック" pitchFamily="34" charset="0"/>
+                          <a:ea typeface="游ゴシック" pitchFamily="34" charset="-122"/>
+                          <a:cs typeface="游ゴシック" pitchFamily="34" charset="-120"/>
+                        </a:rPr>
+                        <a:t>0.296</a:t>
+                      </a:r>
+                      <a:endParaRPr lang="en-US" sz="1100" dirty="0">
+                        <a:latin typeface="游ゴシック" charset="0"/>
+                        <a:ea typeface="游ゴシック" charset="0"/>
+                        <a:cs typeface="游ゴシック" charset="0"/>
+                      </a:endParaRPr>
+                    </a:p>
+                  </a:txBody>
+                  <a:tcPr marL="91440" marR="91440" marT="45720" marB="45720">
+                    <a:lnL w="6350" cap="flat" cmpd="sng" algn="ctr">
+                      <a:solidFill>
+                        <a:srgbClr val="BBBBBB"/>
+                      </a:solidFill>
+                      <a:prstDash val="solid"/>
+                      <a:round/>
+                      <a:headEnd type="none" w="med" len="med"/>
+                      <a:tailEnd type="none" w="med" len="med"/>
+                    </a:lnL>
+                    <a:lnR w="6350" cap="flat" cmpd="sng" algn="ctr">
+                      <a:solidFill>
+                        <a:srgbClr val="BBBBBB"/>
+                      </a:solidFill>
+                      <a:prstDash val="solid"/>
+                      <a:round/>
+                      <a:headEnd type="none" w="med" len="med"/>
+                      <a:tailEnd type="none" w="med" len="med"/>
+                    </a:lnR>
+                    <a:lnT w="6350" cap="flat" cmpd="sng" algn="ctr">
+                      <a:solidFill>
+                        <a:srgbClr val="BBBBBB"/>
+                      </a:solidFill>
+                      <a:prstDash val="solid"/>
+                      <a:round/>
+                      <a:headEnd type="none" w="med" len="med"/>
+                      <a:tailEnd type="none" w="med" len="med"/>
+                    </a:lnT>
+                    <a:lnB w="6350" cap="flat" cmpd="sng" algn="ctr">
+                      <a:solidFill>
+                        <a:srgbClr val="BBBBBB"/>
+                      </a:solidFill>
+                      <a:prstDash val="solid"/>
+                      <a:round/>
+                      <a:headEnd type="none" w="med" len="med"/>
+                      <a:tailEnd type="none" w="med" len="med"/>
+                    </a:lnB>
+                  </a:tcPr>
+                </a:tc>
+                <a:tc>
+                  <a:txBody>
+                    <a:bodyPr/>
+                    <a:lstStyle/>
+                    <a:p>
+                      <a:pPr indent="0" marL="0">
+                        <a:buNone/>
+                      </a:pPr>
+                      <a:r>
+                        <a:rPr lang="en-US" sz="1100" dirty="0">
+                          <a:solidFill>
+                            <a:srgbClr val="222222"/>
+                          </a:solidFill>
+                          <a:latin typeface="游ゴシック" pitchFamily="34" charset="0"/>
+                          <a:ea typeface="游ゴシック" pitchFamily="34" charset="-122"/>
+                          <a:cs typeface="游ゴシック" pitchFamily="34" charset="-120"/>
+                        </a:rPr>
+                        <a:t>0</a:t>
+                      </a:r>
+                      <a:endParaRPr lang="en-US" sz="1100" dirty="0">
+                        <a:latin typeface="游ゴシック" charset="0"/>
+                        <a:ea typeface="游ゴシック" charset="0"/>
+                        <a:cs typeface="游ゴシック" charset="0"/>
+                      </a:endParaRPr>
+                    </a:p>
+                  </a:txBody>
+                  <a:tcPr marL="91440" marR="91440" marT="45720" marB="45720">
+                    <a:lnL w="6350" cap="flat" cmpd="sng" algn="ctr">
+                      <a:solidFill>
+                        <a:srgbClr val="BBBBBB"/>
+                      </a:solidFill>
+                      <a:prstDash val="solid"/>
+                      <a:round/>
+                      <a:headEnd type="none" w="med" len="med"/>
+                      <a:tailEnd type="none" w="med" len="med"/>
+                    </a:lnL>
+                    <a:lnR w="6350" cap="flat" cmpd="sng" algn="ctr">
+                      <a:solidFill>
+                        <a:srgbClr val="BBBBBB"/>
+                      </a:solidFill>
+                      <a:prstDash val="solid"/>
+                      <a:round/>
+                      <a:headEnd type="none" w="med" len="med"/>
+                      <a:tailEnd type="none" w="med" len="med"/>
+                    </a:lnR>
+                    <a:lnT w="6350" cap="flat" cmpd="sng" algn="ctr">
+                      <a:solidFill>
+                        <a:srgbClr val="BBBBBB"/>
+                      </a:solidFill>
+                      <a:prstDash val="solid"/>
+                      <a:round/>
+                      <a:headEnd type="none" w="med" len="med"/>
+                      <a:tailEnd type="none" w="med" len="med"/>
+                    </a:lnT>
+                    <a:lnB w="6350" cap="flat" cmpd="sng" algn="ctr">
+                      <a:solidFill>
+                        <a:srgbClr val="BBBBBB"/>
+                      </a:solidFill>
+                      <a:prstDash val="solid"/>
+                      <a:round/>
+                      <a:headEnd type="none" w="med" len="med"/>
+                      <a:tailEnd type="none" w="med" len="med"/>
+                    </a:lnB>
+                  </a:tcPr>
+                </a:tc>
+                <a:tc>
+                  <a:txBody>
+                    <a:bodyPr/>
+                    <a:lstStyle/>
+                    <a:p>
+                      <a:pPr indent="0" marL="0">
+                        <a:buNone/>
+                      </a:pPr>
+                      <a:r>
+                        <a:rPr lang="en-US" sz="1100" b="1" dirty="0">
+                          <a:solidFill>
+                            <a:srgbClr val="C0504D"/>
+                          </a:solidFill>
+                          <a:latin typeface="游ゴシック" pitchFamily="34" charset="0"/>
+                          <a:ea typeface="游ゴシック" pitchFamily="34" charset="-122"/>
+                          <a:cs typeface="游ゴシック" pitchFamily="34" charset="-120"/>
+                        </a:rPr>
+                        <a:t>研究室</a:t>
+                      </a:r>
+                      <a:endParaRPr lang="en-US" sz="1100" dirty="0">
+                        <a:latin typeface="游ゴシック" charset="0"/>
+                        <a:ea typeface="游ゴシック" charset="0"/>
+                        <a:cs typeface="游ゴシック" charset="0"/>
+                      </a:endParaRPr>
+                    </a:p>
+                  </a:txBody>
+                  <a:tcPr marL="91440" marR="91440" marT="45720" marB="45720">
+                    <a:lnL w="6350" cap="flat" cmpd="sng" algn="ctr">
+                      <a:solidFill>
+                        <a:srgbClr val="BBBBBB"/>
+                      </a:solidFill>
+                      <a:prstDash val="solid"/>
+                      <a:round/>
+                      <a:headEnd type="none" w="med" len="med"/>
+                      <a:tailEnd type="none" w="med" len="med"/>
+                    </a:lnL>
+                    <a:lnR w="6350" cap="flat" cmpd="sng" algn="ctr">
+                      <a:solidFill>
+                        <a:srgbClr val="BBBBBB"/>
+                      </a:solidFill>
+                      <a:prstDash val="solid"/>
+                      <a:round/>
+                      <a:headEnd type="none" w="med" len="med"/>
+                      <a:tailEnd type="none" w="med" len="med"/>
+                    </a:lnR>
+                    <a:lnT w="6350" cap="flat" cmpd="sng" algn="ctr">
+                      <a:solidFill>
+                        <a:srgbClr val="BBBBBB"/>
+                      </a:solidFill>
+                      <a:prstDash val="solid"/>
+                      <a:round/>
+                      <a:headEnd type="none" w="med" len="med"/>
+                      <a:tailEnd type="none" w="med" len="med"/>
+                    </a:lnT>
+                    <a:lnB w="6350" cap="flat" cmpd="sng" algn="ctr">
+                      <a:solidFill>
+                        <a:srgbClr val="BBBBBB"/>
+                      </a:solidFill>
+                      <a:prstDash val="solid"/>
+                      <a:round/>
+                      <a:headEnd type="none" w="med" len="med"/>
+                      <a:tailEnd type="none" w="med" len="med"/>
+                    </a:lnB>
+                  </a:tcPr>
+                </a:tc>
+              </a:tr>
+              <a:tr h="365760">
+                <a:tc>
+                  <a:txBody>
+                    <a:bodyPr/>
+                    <a:lstStyle/>
+                    <a:p>
+                      <a:pPr indent="0" marL="0">
+                        <a:buNone/>
+                      </a:pPr>
+                      <a:r>
+                        <a:rPr lang="en-US" sz="1100" dirty="0">
+                          <a:solidFill>
+                            <a:srgbClr val="222222"/>
+                          </a:solidFill>
+                          <a:latin typeface="游ゴシック" pitchFamily="34" charset="0"/>
+                          <a:ea typeface="游ゴシック" pitchFamily="34" charset="-122"/>
+                          <a:cs typeface="游ゴシック" pitchFamily="34" charset="-120"/>
+                        </a:rPr>
+                        <a:t>大型店の買物：未使用地区での当てはまり</a:t>
+                      </a:r>
+                      <a:endParaRPr lang="en-US" sz="1100" dirty="0">
+                        <a:latin typeface="游ゴシック" charset="0"/>
+                        <a:ea typeface="游ゴシック" charset="0"/>
+                        <a:cs typeface="游ゴシック" charset="0"/>
+                      </a:endParaRPr>
+                    </a:p>
+                  </a:txBody>
+                  <a:tcPr marL="91440" marR="91440" marT="45720" marB="45720">
+                    <a:lnL w="6350" cap="flat" cmpd="sng" algn="ctr">
+                      <a:solidFill>
+                        <a:srgbClr val="BBBBBB"/>
+                      </a:solidFill>
+                      <a:prstDash val="solid"/>
+                      <a:round/>
+                      <a:headEnd type="none" w="med" len="med"/>
+                      <a:tailEnd type="none" w="med" len="med"/>
+                    </a:lnL>
+                    <a:lnR w="6350" cap="flat" cmpd="sng" algn="ctr">
+                      <a:solidFill>
+                        <a:srgbClr val="BBBBBB"/>
+                      </a:solidFill>
+                      <a:prstDash val="solid"/>
+                      <a:round/>
+                      <a:headEnd type="none" w="med" len="med"/>
+                      <a:tailEnd type="none" w="med" len="med"/>
+                    </a:lnR>
+                    <a:lnT w="6350" cap="flat" cmpd="sng" algn="ctr">
+                      <a:solidFill>
+                        <a:srgbClr val="BBBBBB"/>
+                      </a:solidFill>
+                      <a:prstDash val="solid"/>
+                      <a:round/>
+                      <a:headEnd type="none" w="med" len="med"/>
+                      <a:tailEnd type="none" w="med" len="med"/>
+                    </a:lnT>
+                    <a:lnB w="6350" cap="flat" cmpd="sng" algn="ctr">
+                      <a:solidFill>
+                        <a:srgbClr val="BBBBBB"/>
+                      </a:solidFill>
+                      <a:prstDash val="solid"/>
+                      <a:round/>
+                      <a:headEnd type="none" w="med" len="med"/>
+                      <a:tailEnd type="none" w="med" len="med"/>
+                    </a:lnB>
+                  </a:tcPr>
+                </a:tc>
+                <a:tc>
+                  <a:txBody>
+                    <a:bodyPr/>
+                    <a:lstStyle/>
+                    <a:p>
+                      <a:pPr indent="0" marL="0">
+                        <a:buNone/>
+                      </a:pPr>
+                      <a:r>
+                        <a:rPr lang="en-US" sz="1100" dirty="0">
+                          <a:solidFill>
+                            <a:srgbClr val="222222"/>
+                          </a:solidFill>
+                          <a:latin typeface="游ゴシック" pitchFamily="34" charset="0"/>
+                          <a:ea typeface="游ゴシック" pitchFamily="34" charset="-122"/>
+                          <a:cs typeface="游ゴシック" pitchFamily="34" charset="-120"/>
+                        </a:rPr>
+                        <a:t>−1.620</a:t>
+                      </a:r>
+                      <a:endParaRPr lang="en-US" sz="1100" dirty="0">
+                        <a:latin typeface="游ゴシック" charset="0"/>
+                        <a:ea typeface="游ゴシック" charset="0"/>
+                        <a:cs typeface="游ゴシック" charset="0"/>
+                      </a:endParaRPr>
+                    </a:p>
+                  </a:txBody>
+                  <a:tcPr marL="91440" marR="91440" marT="45720" marB="45720">
+                    <a:lnL w="6350" cap="flat" cmpd="sng" algn="ctr">
+                      <a:solidFill>
+                        <a:srgbClr val="BBBBBB"/>
+                      </a:solidFill>
+                      <a:prstDash val="solid"/>
+                      <a:round/>
+                      <a:headEnd type="none" w="med" len="med"/>
+                      <a:tailEnd type="none" w="med" len="med"/>
+                    </a:lnL>
+                    <a:lnR w="6350" cap="flat" cmpd="sng" algn="ctr">
+                      <a:solidFill>
+                        <a:srgbClr val="BBBBBB"/>
+                      </a:solidFill>
+                      <a:prstDash val="solid"/>
+                      <a:round/>
+                      <a:headEnd type="none" w="med" len="med"/>
+                      <a:tailEnd type="none" w="med" len="med"/>
+                    </a:lnR>
+                    <a:lnT w="6350" cap="flat" cmpd="sng" algn="ctr">
+                      <a:solidFill>
+                        <a:srgbClr val="BBBBBB"/>
+                      </a:solidFill>
+                      <a:prstDash val="solid"/>
+                      <a:round/>
+                      <a:headEnd type="none" w="med" len="med"/>
+                      <a:tailEnd type="none" w="med" len="med"/>
+                    </a:lnT>
+                    <a:lnB w="6350" cap="flat" cmpd="sng" algn="ctr">
+                      <a:solidFill>
+                        <a:srgbClr val="BBBBBB"/>
+                      </a:solidFill>
+                      <a:prstDash val="solid"/>
+                      <a:round/>
+                      <a:headEnd type="none" w="med" len="med"/>
+                      <a:tailEnd type="none" w="med" len="med"/>
+                    </a:lnB>
+                  </a:tcPr>
+                </a:tc>
+                <a:tc>
+                  <a:txBody>
+                    <a:bodyPr/>
+                    <a:lstStyle/>
+                    <a:p>
+                      <a:pPr indent="0" marL="0">
+                        <a:buNone/>
+                      </a:pPr>
+                      <a:r>
+                        <a:rPr lang="en-US" sz="1100" dirty="0">
+                          <a:solidFill>
+                            <a:srgbClr val="222222"/>
+                          </a:solidFill>
+                          <a:latin typeface="游ゴシック" pitchFamily="34" charset="0"/>
+                          <a:ea typeface="游ゴシック" pitchFamily="34" charset="-122"/>
+                          <a:cs typeface="游ゴシック" pitchFamily="34" charset="-120"/>
+                        </a:rPr>
+                        <a:t>−1.874（距離0.45）</a:t>
+                      </a:r>
+                      <a:endParaRPr lang="en-US" sz="1100" dirty="0">
+                        <a:latin typeface="游ゴシック" charset="0"/>
+                        <a:ea typeface="游ゴシック" charset="0"/>
+                        <a:cs typeface="游ゴシック" charset="0"/>
+                      </a:endParaRPr>
+                    </a:p>
+                    <a:p>
+                      <a:pPr indent="0" marL="0">
+                        <a:buNone/>
+                      </a:pPr>
+                      <a:r>
+                        <a:rPr lang="en-US" sz="1100" dirty="0">
+                          <a:solidFill>
+                            <a:srgbClr val="222222"/>
+                          </a:solidFill>
+                          <a:latin typeface="游ゴシック" pitchFamily="34" charset="0"/>
+                          <a:ea typeface="游ゴシック" pitchFamily="34" charset="-122"/>
+                          <a:cs typeface="游ゴシック" pitchFamily="34" charset="-120"/>
+                        </a:rPr>
+                        <a:t>−1.579（距離0.78）</a:t>
+                      </a:r>
+                      <a:endParaRPr lang="en-US" sz="1100" dirty="0">
+                        <a:latin typeface="游ゴシック" charset="0"/>
+                        <a:ea typeface="游ゴシック" charset="0"/>
+                        <a:cs typeface="游ゴシック" charset="0"/>
+                      </a:endParaRPr>
+                    </a:p>
+                  </a:txBody>
+                  <a:tcPr marL="91440" marR="91440" marT="45720" marB="45720">
+                    <a:lnL w="6350" cap="flat" cmpd="sng" algn="ctr">
+                      <a:solidFill>
+                        <a:srgbClr val="BBBBBB"/>
+                      </a:solidFill>
+                      <a:prstDash val="solid"/>
+                      <a:round/>
+                      <a:headEnd type="none" w="med" len="med"/>
+                      <a:tailEnd type="none" w="med" len="med"/>
+                    </a:lnL>
+                    <a:lnR w="6350" cap="flat" cmpd="sng" algn="ctr">
+                      <a:solidFill>
+                        <a:srgbClr val="BBBBBB"/>
+                      </a:solidFill>
+                      <a:prstDash val="solid"/>
+                      <a:round/>
+                      <a:headEnd type="none" w="med" len="med"/>
+                      <a:tailEnd type="none" w="med" len="med"/>
+                    </a:lnR>
+                    <a:lnT w="6350" cap="flat" cmpd="sng" algn="ctr">
+                      <a:solidFill>
+                        <a:srgbClr val="BBBBBB"/>
+                      </a:solidFill>
+                      <a:prstDash val="solid"/>
+                      <a:round/>
+                      <a:headEnd type="none" w="med" len="med"/>
+                      <a:tailEnd type="none" w="med" len="med"/>
+                    </a:lnT>
+                    <a:lnB w="6350" cap="flat" cmpd="sng" algn="ctr">
+                      <a:solidFill>
+                        <a:srgbClr val="BBBBBB"/>
+                      </a:solidFill>
+                      <a:prstDash val="solid"/>
+                      <a:round/>
+                      <a:headEnd type="none" w="med" len="med"/>
+                      <a:tailEnd type="none" w="med" len="med"/>
+                    </a:lnB>
+                  </a:tcPr>
+                </a:tc>
+                <a:tc>
+                  <a:txBody>
+                    <a:bodyPr/>
+                    <a:lstStyle/>
+                    <a:p>
+                      <a:pPr indent="0" marL="0">
+                        <a:buNone/>
+                      </a:pPr>
+                      <a:r>
+                        <a:rPr lang="en-US" sz="1100" dirty="0">
+                          <a:solidFill>
+                            <a:srgbClr val="222222"/>
+                          </a:solidFill>
+                          <a:latin typeface="游ゴシック" pitchFamily="34" charset="0"/>
+                          <a:ea typeface="游ゴシック" pitchFamily="34" charset="-122"/>
+                          <a:cs typeface="游ゴシック" pitchFamily="34" charset="-120"/>
+                        </a:rPr>
+                        <a:t>大きい方が良</a:t>
+                      </a:r>
+                      <a:endParaRPr lang="en-US" sz="1100" dirty="0">
+                        <a:latin typeface="游ゴシック" charset="0"/>
+                        <a:ea typeface="游ゴシック" charset="0"/>
+                        <a:cs typeface="游ゴシック" charset="0"/>
+                      </a:endParaRPr>
+                    </a:p>
+                  </a:txBody>
+                  <a:tcPr marL="91440" marR="91440" marT="45720" marB="45720">
+                    <a:lnL w="6350" cap="flat" cmpd="sng" algn="ctr">
+                      <a:solidFill>
+                        <a:srgbClr val="BBBBBB"/>
+                      </a:solidFill>
+                      <a:prstDash val="solid"/>
+                      <a:round/>
+                      <a:headEnd type="none" w="med" len="med"/>
+                      <a:tailEnd type="none" w="med" len="med"/>
+                    </a:lnL>
+                    <a:lnR w="6350" cap="flat" cmpd="sng" algn="ctr">
+                      <a:solidFill>
+                        <a:srgbClr val="BBBBBB"/>
+                      </a:solidFill>
+                      <a:prstDash val="solid"/>
+                      <a:round/>
+                      <a:headEnd type="none" w="med" len="med"/>
+                      <a:tailEnd type="none" w="med" len="med"/>
+                    </a:lnR>
+                    <a:lnT w="6350" cap="flat" cmpd="sng" algn="ctr">
+                      <a:solidFill>
+                        <a:srgbClr val="BBBBBB"/>
+                      </a:solidFill>
+                      <a:prstDash val="solid"/>
+                      <a:round/>
+                      <a:headEnd type="none" w="med" len="med"/>
+                      <a:tailEnd type="none" w="med" len="med"/>
+                    </a:lnT>
+                    <a:lnB w="6350" cap="flat" cmpd="sng" algn="ctr">
+                      <a:solidFill>
+                        <a:srgbClr val="BBBBBB"/>
+                      </a:solidFill>
+                      <a:prstDash val="solid"/>
+                      <a:round/>
+                      <a:headEnd type="none" w="med" len="med"/>
+                      <a:tailEnd type="none" w="med" len="med"/>
+                    </a:lnB>
+                  </a:tcPr>
+                </a:tc>
+                <a:tc>
+                  <a:txBody>
+                    <a:bodyPr/>
+                    <a:lstStyle/>
+                    <a:p>
+                      <a:pPr indent="0" marL="0">
+                        <a:buNone/>
+                      </a:pPr>
+                      <a:r>
+                        <a:rPr lang="en-US" sz="1100" b="1" dirty="0">
+                          <a:solidFill>
+                            <a:srgbClr val="C0504D"/>
+                          </a:solidFill>
+                          <a:latin typeface="游ゴシック" pitchFamily="34" charset="0"/>
+                          <a:ea typeface="游ゴシック" pitchFamily="34" charset="-122"/>
+                          <a:cs typeface="游ゴシック" pitchFamily="34" charset="-120"/>
+                        </a:rPr>
+                        <a:t>研究室</a:t>
+                      </a:r>
+                      <a:endParaRPr lang="en-US" sz="1100" dirty="0">
+                        <a:latin typeface="游ゴシック" charset="0"/>
+                        <a:ea typeface="游ゴシック" charset="0"/>
+                        <a:cs typeface="游ゴシック" charset="0"/>
+                      </a:endParaRPr>
+                    </a:p>
+                  </a:txBody>
+                  <a:tcPr marL="91440" marR="91440" marT="45720" marB="45720">
+                    <a:lnL w="6350" cap="flat" cmpd="sng" algn="ctr">
+                      <a:solidFill>
+                        <a:srgbClr val="BBBBBB"/>
+                      </a:solidFill>
+                      <a:prstDash val="solid"/>
+                      <a:round/>
+                      <a:headEnd type="none" w="med" len="med"/>
+                      <a:tailEnd type="none" w="med" len="med"/>
+                    </a:lnL>
+                    <a:lnR w="6350" cap="flat" cmpd="sng" algn="ctr">
+                      <a:solidFill>
+                        <a:srgbClr val="BBBBBB"/>
+                      </a:solidFill>
+                      <a:prstDash val="solid"/>
+                      <a:round/>
+                      <a:headEnd type="none" w="med" len="med"/>
+                      <a:tailEnd type="none" w="med" len="med"/>
+                    </a:lnR>
+                    <a:lnT w="6350" cap="flat" cmpd="sng" algn="ctr">
+                      <a:solidFill>
+                        <a:srgbClr val="BBBBBB"/>
+                      </a:solidFill>
+                      <a:prstDash val="solid"/>
+                      <a:round/>
+                      <a:headEnd type="none" w="med" len="med"/>
+                      <a:tailEnd type="none" w="med" len="med"/>
+                    </a:lnT>
+                    <a:lnB w="6350" cap="flat" cmpd="sng" algn="ctr">
+                      <a:solidFill>
+                        <a:srgbClr val="BBBBBB"/>
+                      </a:solidFill>
+                      <a:prstDash val="solid"/>
+                      <a:round/>
+                      <a:headEnd type="none" w="med" len="med"/>
+                      <a:tailEnd type="none" w="med" len="med"/>
+                    </a:lnB>
+                  </a:tcPr>
+                </a:tc>
+              </a:tr>
+            </a:tbl>
+          </a:graphicData>
+        </a:graphic>
+      </p:graphicFrame>
+      <p:sp>
+        <p:nvSpPr>
+          <p:cNvPr id="4" name="Text 1"/>
+          <p:cNvSpPr txBox="1"/>
+          <p:nvPr/>
+        </p:nvSpPr>
+        <p:spPr>
+          <a:xfrm>
+            <a:off x="365760" y="4160520"/>
+            <a:ext cx="8412480" cy="502920"/>
+          </a:xfrm>
+          <a:prstGeom prst="rect">
+            <a:avLst/>
+          </a:prstGeom>
+          <a:noFill/>
+          <a:ln/>
+        </p:spPr>
+        <p:txBody>
+          <a:bodyPr wrap="square" lIns="0" tIns="0" rIns="0" bIns="0" rtlCol="0" anchor="t"/>
+          <a:lstStyle/>
+          <a:p>
+            <a:pPr indent="0" marL="0">
+              <a:buNone/>
+            </a:pPr>
+            <a:r>
+              <a:rPr lang="en-US" sz="1200" dirty="0">
+                <a:solidFill>
+                  <a:srgbClr val="222222"/>
+                </a:solidFill>
+                <a:latin typeface="游ゴシック" pitchFamily="34" charset="0"/>
+                <a:ea typeface="游ゴシック" pitchFamily="34" charset="-122"/>
+                <a:cs typeface="游ゴシック" pitchFamily="34" charset="-120"/>
+              </a:rPr>
+              <a:t>大型店の距離の効きを、施設の出発地に合うよう0.45まで弱めた代わりに、愛知全体では遠出が増え、近場の買物の再現は研究室モデルより悪くなった</a:t>
+            </a:r>
+            <a:endParaRPr lang="en-US" sz="1200" dirty="0"/>
+          </a:p>
+        </p:txBody>
+      </p:sp>
+      <p:sp>
+        <p:nvSpPr>
+          <p:cNvPr id="5" name="Text 2"/>
+          <p:cNvSpPr txBox="1"/>
+          <p:nvPr/>
+        </p:nvSpPr>
+        <p:spPr>
+          <a:xfrm>
+            <a:off x="365760" y="4709160"/>
+            <a:ext cx="8412480" cy="274320"/>
+          </a:xfrm>
+          <a:prstGeom prst="rect">
+            <a:avLst/>
+          </a:prstGeom>
+          <a:noFill/>
+          <a:ln/>
+        </p:spPr>
+        <p:txBody>
+          <a:bodyPr wrap="square" lIns="0" tIns="0" rIns="0" bIns="0" rtlCol="0" anchor="ctr"/>
+          <a:lstStyle/>
+          <a:p>
+            <a:pPr indent="0" marL="0">
+              <a:buNone/>
+            </a:pPr>
+            <a:r>
+              <a:rPr lang="en-US" sz="1000" dirty="0">
+                <a:solidFill>
+                  <a:srgbClr val="666666"/>
+                </a:solidFill>
+                <a:latin typeface="游ゴシック" pitchFamily="34" charset="0"/>
+                <a:ea typeface="游ゴシック" pitchFamily="34" charset="-122"/>
+                <a:cs typeface="游ゴシック" pitchFamily="34" charset="-120"/>
+              </a:rPr>
+              <a:t>愛知2%・seed42のbaseline（施設なし）と、Pythonで再現した行き先選択モデル（中京PT、出発地域をtrain/validation/testに分割）での値</a:t>
+            </a:r>
+            <a:endParaRPr lang="en-US" sz="1000" dirty="0"/>
+          </a:p>
+        </p:txBody>
+      </p:sp>
+    </p:spTree>
+  </p:cSld>
+  <p:clrMapOvr>
+    <a:masterClrMapping/>
+  </p:clrMapOvr>
+</p:sld>
+</file>
+
+<file path=ppt/slides/slide8.xml><?xml version="1.0" encoding="utf-8"?>
+<p:sld xmlns:a="http://schemas.openxmlformats.org/drawingml/2006/main" xmlns:r="http://schemas.openxmlformats.org/officeDocument/2006/relationships" xmlns:p="http://schemas.openxmlformats.org/presentationml/2006/main">
+  <p:cSld name="Slide 8">
+    <p:spTree>
+      <p:nvGrpSpPr>
+        <p:cNvPr id="1" name=""/>
+        <p:cNvGrpSpPr/>
+        <p:nvPr/>
+      </p:nvGrpSpPr>
+      <p:grpSpPr>
+        <a:xfrm>
+          <a:off x="0" y="0"/>
+          <a:ext cx="0" cy="0"/>
+          <a:chOff x="0" y="0"/>
+          <a:chExt cx="0" cy="0"/>
+        </a:xfrm>
+      </p:grpSpPr>
+      <p:sp>
+        <p:nvSpPr>
+          <p:cNvPr id="2" name="Text 0"/>
+          <p:cNvSpPr txBox="1"/>
+          <p:nvPr/>
+        </p:nvSpPr>
+        <p:spPr>
+          <a:xfrm>
+            <a:off x="365760" y="182880"/>
+            <a:ext cx="8412480" cy="548640"/>
+          </a:xfrm>
+          <a:prstGeom prst="rect">
+            <a:avLst/>
+          </a:prstGeom>
+          <a:noFill/>
+          <a:ln/>
+        </p:spPr>
+        <p:txBody>
+          <a:bodyPr wrap="square" lIns="0" tIns="0" rIns="0" bIns="0" rtlCol="0" anchor="ctr"/>
+          <a:lstStyle/>
+          <a:p>
+            <a:pPr indent="0" marL="0">
+              <a:buNone/>
+            </a:pPr>
+            <a:r>
+              <a:rPr lang="en-US" sz="2800" b="1" dirty="0">
+                <a:solidFill>
+                  <a:srgbClr val="222222"/>
+                </a:solidFill>
+                <a:latin typeface="游ゴシック" pitchFamily="34" charset="0"/>
+                <a:ea typeface="游ゴシック" pitchFamily="34" charset="-122"/>
+                <a:cs typeface="游ゴシック" pitchFamily="34" charset="-120"/>
+              </a:rPr>
+              <a:t>精度④　全数（100%）で実行した結果</a:t>
             </a:r>
             <a:endParaRPr lang="en-US" sz="2800" dirty="0"/>
           </a:p>
@@ -8421,9 +10995,9 @@
 </p:sld>
 </file>
 
-<file path=ppt/slides/slide8.xml><?xml version="1.0" encoding="utf-8"?>
+<file path=ppt/slides/slide9.xml><?xml version="1.0" encoding="utf-8"?>
 <p:sld xmlns:a="http://schemas.openxmlformats.org/drawingml/2006/main" xmlns:r="http://schemas.openxmlformats.org/officeDocument/2006/relationships" xmlns:p="http://schemas.openxmlformats.org/presentationml/2006/main">
-  <p:cSld name="Slide 8">
+  <p:cSld name="Slide 9">
     <p:spTree>
       <p:nvGrpSpPr>
         <p:cNvPr id="1" name=""/>

</xml_diff>